<commit_message>
Links: state what the fixture can and cannot show, make the week-one link audit the gate for Q1 order
Adds partial correlations (age vs drop with links held constant 0.80;
links vs drop with age held constant -0.07) to the analysis, and
replaces 'links are not the problem' with the open link hypotheses,
the tests that settle them, and what changes in the plan if they hit.

Co-Authored-By: Claude Fable 5.1 <noreply@anthropic.com>
Claude-Session: https://claude.ai/code/session_015LEzkrfcXznaX9ERkNGL27
</commit_message>
<xml_diff>
--- a/deck/SEO_recovery_plan_client_deck.pptx
+++ b/deck/SEO_recovery_plan_client_deck.pptx
@@ -12850,7 +12850,7 @@
                 <a:ea typeface="Arial" pitchFamily="34" charset="-122"/>
                 <a:cs typeface="Arial" pitchFamily="34" charset="-120"/>
               </a:rPr>
-              <a:t>WHAT IT IS NOT</a:t>
+              <a:t>WHAT IT IS PROBABLY NOT</a:t>
             </a:r>
             <a:endParaRPr lang="en-US" sz="1100" dirty="0"/>
           </a:p>
@@ -12889,7 +12889,7 @@
                 <a:ea typeface="Arial" pitchFamily="34" charset="-122"/>
                 <a:cs typeface="Arial" pitchFamily="34" charset="-120"/>
               </a:rPr>
-              <a:t>This is not a Google penalty and not a shortage of links. Your best-linked pages fell too.</a:t>
+              <a:t>The data points to page age, not to links or a penalty. We confirm that in week one, before spending on either.</a:t>
             </a:r>
             <a:endParaRPr lang="en-US" sz="2600" dirty="0"/>
           </a:p>
@@ -13078,7 +13078,7 @@
                 <a:ea typeface="Arial" pitchFamily="34" charset="-122"/>
                 <a:cs typeface="Arial" pitchFamily="34" charset="-120"/>
               </a:rPr>
-              <a:t>Three signs this is not a penalty</a:t>
+              <a:t>Three signs it is page age, not links</a:t>
             </a:r>
             <a:endParaRPr lang="en-US" sz="1150" dirty="0"/>
           </a:p>
@@ -13140,7 +13140,7 @@
                 <a:ea typeface="Arial" pitchFamily="34" charset="-122"/>
                 <a:cs typeface="Arial" pitchFamily="34" charset="-120"/>
               </a:rPr>
-              <a:t>The four pages with the most links all fell. The two that grew have far fewer. Links did not decide this.</a:t>
+              <a:t>Your best-linked pages fell the least, 2 to 5 places. The pages that fell 17 to 38 places have the fewest links.</a:t>
             </a:r>
             <a:endParaRPr lang="en-US" sz="1150" dirty="0"/>
           </a:p>
@@ -13161,7 +13161,7 @@
                 <a:ea typeface="Arial" pitchFamily="34" charset="-122"/>
                 <a:cs typeface="Arial" pitchFamily="34" charset="-120"/>
               </a:rPr>
-              <a:t>The drops match page age, not link counts.</a:t>
+              <a:t>Once page age is taken into account, link counts explain none of the drop.</a:t>
             </a:r>
             <a:endParaRPr lang="en-US" sz="1150" dirty="0"/>
           </a:p>
@@ -13201,7 +13201,7 @@
                 <a:ea typeface="Arial" pitchFamily="34" charset="-122"/>
                 <a:cs typeface="Arial" pitchFamily="34" charset="-120"/>
               </a:rPr>
-              <a:t>We will still run a full check of your link profile in week one. If anything looks manufactured, we deal with it first. We do not expect to find it.</a:t>
+              <a:t>What this data cannot see: whether any of your links are poor quality, whether links were lost this year, or whether competitors simply out-built you. The week-one link check covers all three. If it finds a problem, the order flips: links first, rewriting second.</a:t>
             </a:r>
             <a:endParaRPr lang="en-US" sz="1150" dirty="0"/>
           </a:p>
@@ -13290,7 +13290,7 @@
                 <a:ea typeface="Arial" pitchFamily="34" charset="-122"/>
                 <a:cs typeface="Arial" pitchFamily="34" charset="-120"/>
               </a:rPr>
-              <a:t>Buying or chasing links would be money spent on the wrong problem. The fix is the content and the pages themselves.</a:t>
+              <a:t>The first month looks the same either way: fix the comparison page, redirect the expired pages, run the link check. Its result decides the next five months.</a:t>
             </a:r>
             <a:endParaRPr lang="en-US" sz="1300" dirty="0"/>
           </a:p>

</xml_diff>

<commit_message>
Month-12 targets as low/base/stretch scenarios; scaled sample input labeled as a scenario assumption; tighter prose
- Targets_Month_12 now carries three scenarios (101K / 117K / 136K;
  1.5x / 2.2x / 3x conversions) with the head-term scaling called out
  as a scenario assumption that week-one Search Console data replaces.
- Removed the unsupported DR 62 line and the unevidenced past-work
  anecdote (and its Tier 0 evidence row).
- Copy-edit pass for concision; no numbers or claims removed.
- Deck slide 12 shows the three scenarios.

Co-Authored-By: Claude Fable 5.1 <noreply@anthropic.com>
Claude-Session: https://claude.ai/code/session_015LEzkrfcXznaX9ERkNGL27
</commit_message>
<xml_diff>
--- a/deck/SEO_recovery_plan_client_deck.pptx
+++ b/deck/SEO_recovery_plan_client_deck.pptx
@@ -1920,7 +1920,7 @@
                 </a:solidFill>
                 <a:latin typeface="Arial"/>
               </a:rPr>
-              <a:t>Monthly visits from Google (projection)</a:t>
+              <a:t>Monthly visits from Google (three scenarios)</a:t>
             </a:r>
           </a:p>
         </c:rich>
@@ -1942,18 +1942,18 @@
               <c:strCache>
                 <c:ptCount val="1"/>
                 <c:pt idx="0">
-                  <c:v>Monthly visits (projection)</c:v>
+                  <c:v>Stretch</c:v>
                 </c:pt>
               </c:strCache>
             </c:strRef>
           </c:tx>
           <c:spPr>
             <a:solidFill>
-              <a:srgbClr val="F27038"/>
+              <a:srgbClr val="929194"/>
             </a:solidFill>
             <a:ln w="31750" cap="flat">
               <a:solidFill>
-                <a:srgbClr val="F27038"/>
+                <a:srgbClr val="929194"/>
               </a:solidFill>
               <a:prstDash val="solid"/>
               <a:round/>
@@ -1977,9 +1977,8 @@
                 </a:pPr>
               </a:p>
             </c:txPr>
-            <c:dLblPos val="t"/>
             <c:showLegendKey val="0"/>
-            <c:showVal val="1"/>
+            <c:showVal val="0"/>
             <c:showCatName val="0"/>
             <c:showSerName val="0"/>
             <c:showPercent val="0"/>
@@ -1988,14 +1987,14 @@
           </c:dLbls>
           <c:marker>
             <c:symbol val="circle"/>
-            <c:size val="8"/>
+            <c:size val="7"/>
             <c:spPr>
               <a:solidFill>
-                <a:srgbClr val="F27038"/>
+                <a:srgbClr val="929194"/>
               </a:solidFill>
               <a:ln w="9525" cap="flat">
                 <a:solidFill>
-                  <a:srgbClr val="F27038"/>
+                  <a:srgbClr val="929194"/>
                 </a:solidFill>
                 <a:prstDash val="solid"/>
                 <a:round/>
@@ -2038,6 +2037,126 @@
                   <c:v>85000</c:v>
                 </c:pt>
                 <c:pt idx="1">
+                  <c:v>95000</c:v>
+                </c:pt>
+                <c:pt idx="2">
+                  <c:v>112000</c:v>
+                </c:pt>
+                <c:pt idx="3">
+                  <c:v>126000</c:v>
+                </c:pt>
+                <c:pt idx="4">
+                  <c:v>136000</c:v>
+                </c:pt>
+              </c:numCache>
+            </c:numRef>
+          </c:val>
+          <c:smooth val="0"/>
+        </c:ser>
+        <c:ser>
+          <c:idx val="1"/>
+          <c:order val="1"/>
+          <c:tx>
+            <c:strRef>
+              <c:f>Sheet1!$C$1</c:f>
+              <c:strCache>
+                <c:ptCount val="1"/>
+                <c:pt idx="0">
+                  <c:v>Base</c:v>
+                </c:pt>
+              </c:strCache>
+            </c:strRef>
+          </c:tx>
+          <c:spPr>
+            <a:solidFill>
+              <a:srgbClr val="F27038"/>
+            </a:solidFill>
+            <a:ln w="31750" cap="flat">
+              <a:solidFill>
+                <a:srgbClr val="F27038"/>
+              </a:solidFill>
+              <a:prstDash val="solid"/>
+              <a:round/>
+            </a:ln>
+            <a:effectLst/>
+          </c:spPr>
+          <c:invertIfNegative val="0"/>
+          <c:dLbls>
+            <c:numFmt formatCode="#,##0" sourceLinked="0"/>
+            <c:txPr>
+              <a:bodyPr/>
+              <a:lstStyle/>
+              <a:p>
+                <a:pPr>
+                  <a:defRPr b="0" i="0" strike="noStrike" sz="1100" u="none">
+                    <a:solidFill>
+                      <a:srgbClr val="2C2F33"/>
+                    </a:solidFill>
+                    <a:latin typeface="Arial"/>
+                  </a:defRPr>
+                </a:pPr>
+              </a:p>
+            </c:txPr>
+            <c:showLegendKey val="0"/>
+            <c:showVal val="0"/>
+            <c:showCatName val="0"/>
+            <c:showSerName val="0"/>
+            <c:showPercent val="0"/>
+            <c:showBubbleSize val="0"/>
+            <c:showLeaderLines val="0"/>
+          </c:dLbls>
+          <c:marker>
+            <c:symbol val="circle"/>
+            <c:size val="7"/>
+            <c:spPr>
+              <a:solidFill>
+                <a:srgbClr val="F27038"/>
+              </a:solidFill>
+              <a:ln w="9525" cap="flat">
+                <a:solidFill>
+                  <a:srgbClr val="F27038"/>
+                </a:solidFill>
+                <a:prstDash val="solid"/>
+                <a:round/>
+              </a:ln>
+              <a:effectLst/>
+            </c:spPr>
+          </c:marker>
+          <c:cat>
+            <c:multiLvlStrRef>
+              <c:f>Sheet1!$A$2:$A$6</c:f>
+              <c:multiLvlStrCache>
+                <c:ptCount val="5"/>
+                <c:lvl>
+                  <c:pt idx="0">
+                    <c:v>Today</c:v>
+                  </c:pt>
+                  <c:pt idx="1">
+                    <c:v>Month 3</c:v>
+                  </c:pt>
+                  <c:pt idx="2">
+                    <c:v>Month 6</c:v>
+                  </c:pt>
+                  <c:pt idx="3">
+                    <c:v>Month 9</c:v>
+                  </c:pt>
+                  <c:pt idx="4">
+                    <c:v>Month 12</c:v>
+                  </c:pt>
+                </c:lvl>
+              </c:multiLvlStrCache>
+            </c:multiLvlStrRef>
+          </c:cat>
+          <c:val>
+            <c:numRef>
+              <c:f>Sheet1!$C$2:$C$6</c:f>
+              <c:numCache>
+                <c:formatCode>General</c:formatCode>
+                <c:ptCount val="5"/>
+                <c:pt idx="0">
+                  <c:v>85000</c:v>
+                </c:pt>
+                <c:pt idx="1">
                   <c:v>92000</c:v>
                 </c:pt>
                 <c:pt idx="2">
@@ -2048,6 +2167,126 @@
                 </c:pt>
                 <c:pt idx="4">
                   <c:v>117000</c:v>
+                </c:pt>
+              </c:numCache>
+            </c:numRef>
+          </c:val>
+          <c:smooth val="0"/>
+        </c:ser>
+        <c:ser>
+          <c:idx val="2"/>
+          <c:order val="2"/>
+          <c:tx>
+            <c:strRef>
+              <c:f>Sheet1!$D$1</c:f>
+              <c:strCache>
+                <c:ptCount val="1"/>
+                <c:pt idx="0">
+                  <c:v>Low</c:v>
+                </c:pt>
+              </c:strCache>
+            </c:strRef>
+          </c:tx>
+          <c:spPr>
+            <a:solidFill>
+              <a:srgbClr val="929194"/>
+            </a:solidFill>
+            <a:ln w="31750" cap="flat">
+              <a:solidFill>
+                <a:srgbClr val="929194"/>
+              </a:solidFill>
+              <a:prstDash val="solid"/>
+              <a:round/>
+            </a:ln>
+            <a:effectLst/>
+          </c:spPr>
+          <c:invertIfNegative val="0"/>
+          <c:dLbls>
+            <c:numFmt formatCode="#,##0" sourceLinked="0"/>
+            <c:txPr>
+              <a:bodyPr/>
+              <a:lstStyle/>
+              <a:p>
+                <a:pPr>
+                  <a:defRPr b="0" i="0" strike="noStrike" sz="1100" u="none">
+                    <a:solidFill>
+                      <a:srgbClr val="2C2F33"/>
+                    </a:solidFill>
+                    <a:latin typeface="Arial"/>
+                  </a:defRPr>
+                </a:pPr>
+              </a:p>
+            </c:txPr>
+            <c:showLegendKey val="0"/>
+            <c:showVal val="0"/>
+            <c:showCatName val="0"/>
+            <c:showSerName val="0"/>
+            <c:showPercent val="0"/>
+            <c:showBubbleSize val="0"/>
+            <c:showLeaderLines val="0"/>
+          </c:dLbls>
+          <c:marker>
+            <c:symbol val="circle"/>
+            <c:size val="7"/>
+            <c:spPr>
+              <a:solidFill>
+                <a:srgbClr val="929194"/>
+              </a:solidFill>
+              <a:ln w="9525" cap="flat">
+                <a:solidFill>
+                  <a:srgbClr val="929194"/>
+                </a:solidFill>
+                <a:prstDash val="solid"/>
+                <a:round/>
+              </a:ln>
+              <a:effectLst/>
+            </c:spPr>
+          </c:marker>
+          <c:cat>
+            <c:multiLvlStrRef>
+              <c:f>Sheet1!$A$2:$A$6</c:f>
+              <c:multiLvlStrCache>
+                <c:ptCount val="5"/>
+                <c:lvl>
+                  <c:pt idx="0">
+                    <c:v>Today</c:v>
+                  </c:pt>
+                  <c:pt idx="1">
+                    <c:v>Month 3</c:v>
+                  </c:pt>
+                  <c:pt idx="2">
+                    <c:v>Month 6</c:v>
+                  </c:pt>
+                  <c:pt idx="3">
+                    <c:v>Month 9</c:v>
+                  </c:pt>
+                  <c:pt idx="4">
+                    <c:v>Month 12</c:v>
+                  </c:pt>
+                </c:lvl>
+              </c:multiLvlStrCache>
+            </c:multiLvlStrRef>
+          </c:cat>
+          <c:val>
+            <c:numRef>
+              <c:f>Sheet1!$D$2:$D$6</c:f>
+              <c:numCache>
+                <c:formatCode>General</c:formatCode>
+                <c:ptCount val="5"/>
+                <c:pt idx="0">
+                  <c:v>85000</c:v>
+                </c:pt>
+                <c:pt idx="1">
+                  <c:v>88000</c:v>
+                </c:pt>
+                <c:pt idx="2">
+                  <c:v>93000</c:v>
+                </c:pt>
+                <c:pt idx="3">
+                  <c:v>98000</c:v>
+                </c:pt>
+                <c:pt idx="4">
+                  <c:v>101000</c:v>
                 </c:pt>
               </c:numCache>
             </c:numRef>
@@ -2070,9 +2309,8 @@
               </a:pPr>
             </a:p>
           </c:txPr>
-          <c:dLblPos val="t"/>
           <c:showLegendKey val="0"/>
-          <c:showVal val="1"/>
+          <c:showVal val="0"/>
           <c:showCatName val="0"/>
           <c:showSerName val="0"/>
           <c:showPercent val="0"/>
@@ -2183,6 +2421,26 @@
         <a:effectLst/>
       </c:spPr>
     </c:plotArea>
+    <c:legend>
+      <c:legendPos val="b"/>
+      <c:overlay val="0"/>
+      <c:txPr>
+        <a:bodyPr/>
+        <a:lstStyle/>
+        <a:p>
+          <a:pPr>
+            <a:defRPr sz="1000">
+              <a:solidFill>
+                <a:srgbClr val="2C2F33"/>
+              </a:solidFill>
+              <a:latin typeface="Arial"/>
+              <a:cs typeface="Arial"/>
+            </a:defRPr>
+          </a:pPr>
+          <a:endParaRPr lang="en-US"/>
+        </a:p>
+      </c:txPr>
+    </c:legend>
     <c:plotVisOnly val="1"/>
     <c:dispBlanksAs val="span"/>
   </c:chart>
@@ -2225,7 +2483,7 @@
                 </a:solidFill>
                 <a:latin typeface="Arial"/>
               </a:rPr>
-              <a:t>Qualified leads from search, indexed to today = 100 (projection)</a:t>
+              <a:t>Qualified leads from search, today = 100 (three scenarios)</a:t>
             </a:r>
           </a:p>
         </c:rich>
@@ -2247,18 +2505,18 @@
               <c:strCache>
                 <c:ptCount val="1"/>
                 <c:pt idx="0">
-                  <c:v>Qualified leads (today = 100)</c:v>
+                  <c:v>Stretch</c:v>
                 </c:pt>
               </c:strCache>
             </c:strRef>
           </c:tx>
           <c:spPr>
             <a:solidFill>
-              <a:srgbClr val="2F343A"/>
+              <a:srgbClr val="929194"/>
             </a:solidFill>
             <a:ln w="31750" cap="flat">
               <a:solidFill>
-                <a:srgbClr val="2F343A"/>
+                <a:srgbClr val="929194"/>
               </a:solidFill>
               <a:prstDash val="solid"/>
               <a:round/>
@@ -2267,7 +2525,7 @@
           </c:spPr>
           <c:invertIfNegative val="0"/>
           <c:dLbls>
-            <c:numFmt formatCode="0" sourceLinked="0"/>
+            <c:numFmt formatCode="#,##0" sourceLinked="0"/>
             <c:txPr>
               <a:bodyPr/>
               <a:lstStyle/>
@@ -2282,9 +2540,8 @@
                 </a:pPr>
               </a:p>
             </c:txPr>
-            <c:dLblPos val="t"/>
             <c:showLegendKey val="0"/>
-            <c:showVal val="1"/>
+            <c:showVal val="0"/>
             <c:showCatName val="0"/>
             <c:showSerName val="0"/>
             <c:showPercent val="0"/>
@@ -2293,14 +2550,14 @@
           </c:dLbls>
           <c:marker>
             <c:symbol val="circle"/>
-            <c:size val="8"/>
+            <c:size val="7"/>
             <c:spPr>
               <a:solidFill>
-                <a:srgbClr val="2F343A"/>
+                <a:srgbClr val="929194"/>
               </a:solidFill>
               <a:ln w="9525" cap="flat">
                 <a:solidFill>
-                  <a:srgbClr val="2F343A"/>
+                  <a:srgbClr val="929194"/>
                 </a:solidFill>
                 <a:prstDash val="solid"/>
                 <a:round/>
@@ -2343,6 +2600,126 @@
                   <c:v>100</c:v>
                 </c:pt>
                 <c:pt idx="1">
+                  <c:v>125</c:v>
+                </c:pt>
+                <c:pt idx="2">
+                  <c:v>180</c:v>
+                </c:pt>
+                <c:pt idx="3">
+                  <c:v>245</c:v>
+                </c:pt>
+                <c:pt idx="4">
+                  <c:v>304</c:v>
+                </c:pt>
+              </c:numCache>
+            </c:numRef>
+          </c:val>
+          <c:smooth val="0"/>
+        </c:ser>
+        <c:ser>
+          <c:idx val="1"/>
+          <c:order val="1"/>
+          <c:tx>
+            <c:strRef>
+              <c:f>Sheet1!$C$1</c:f>
+              <c:strCache>
+                <c:ptCount val="1"/>
+                <c:pt idx="0">
+                  <c:v>Base</c:v>
+                </c:pt>
+              </c:strCache>
+            </c:strRef>
+          </c:tx>
+          <c:spPr>
+            <a:solidFill>
+              <a:srgbClr val="2F343A"/>
+            </a:solidFill>
+            <a:ln w="31750" cap="flat">
+              <a:solidFill>
+                <a:srgbClr val="2F343A"/>
+              </a:solidFill>
+              <a:prstDash val="solid"/>
+              <a:round/>
+            </a:ln>
+            <a:effectLst/>
+          </c:spPr>
+          <c:invertIfNegative val="0"/>
+          <c:dLbls>
+            <c:numFmt formatCode="#,##0" sourceLinked="0"/>
+            <c:txPr>
+              <a:bodyPr/>
+              <a:lstStyle/>
+              <a:p>
+                <a:pPr>
+                  <a:defRPr b="0" i="0" strike="noStrike" sz="1100" u="none">
+                    <a:solidFill>
+                      <a:srgbClr val="2C2F33"/>
+                    </a:solidFill>
+                    <a:latin typeface="Arial"/>
+                  </a:defRPr>
+                </a:pPr>
+              </a:p>
+            </c:txPr>
+            <c:showLegendKey val="0"/>
+            <c:showVal val="0"/>
+            <c:showCatName val="0"/>
+            <c:showSerName val="0"/>
+            <c:showPercent val="0"/>
+            <c:showBubbleSize val="0"/>
+            <c:showLeaderLines val="0"/>
+          </c:dLbls>
+          <c:marker>
+            <c:symbol val="circle"/>
+            <c:size val="7"/>
+            <c:spPr>
+              <a:solidFill>
+                <a:srgbClr val="2F343A"/>
+              </a:solidFill>
+              <a:ln w="9525" cap="flat">
+                <a:solidFill>
+                  <a:srgbClr val="2F343A"/>
+                </a:solidFill>
+                <a:prstDash val="solid"/>
+                <a:round/>
+              </a:ln>
+              <a:effectLst/>
+            </c:spPr>
+          </c:marker>
+          <c:cat>
+            <c:multiLvlStrRef>
+              <c:f>Sheet1!$A$2:$A$6</c:f>
+              <c:multiLvlStrCache>
+                <c:ptCount val="5"/>
+                <c:lvl>
+                  <c:pt idx="0">
+                    <c:v>Today</c:v>
+                  </c:pt>
+                  <c:pt idx="1">
+                    <c:v>Month 3</c:v>
+                  </c:pt>
+                  <c:pt idx="2">
+                    <c:v>Month 6</c:v>
+                  </c:pt>
+                  <c:pt idx="3">
+                    <c:v>Month 9</c:v>
+                  </c:pt>
+                  <c:pt idx="4">
+                    <c:v>Month 12</c:v>
+                  </c:pt>
+                </c:lvl>
+              </c:multiLvlStrCache>
+            </c:multiLvlStrRef>
+          </c:cat>
+          <c:val>
+            <c:numRef>
+              <c:f>Sheet1!$C$2:$C$6</c:f>
+              <c:numCache>
+                <c:formatCode>General</c:formatCode>
+                <c:ptCount val="5"/>
+                <c:pt idx="0">
+                  <c:v>100</c:v>
+                </c:pt>
+                <c:pt idx="1">
                   <c:v>115</c:v>
                 </c:pt>
                 <c:pt idx="2">
@@ -2359,8 +2736,128 @@
           </c:val>
           <c:smooth val="0"/>
         </c:ser>
+        <c:ser>
+          <c:idx val="2"/>
+          <c:order val="2"/>
+          <c:tx>
+            <c:strRef>
+              <c:f>Sheet1!$D$1</c:f>
+              <c:strCache>
+                <c:ptCount val="1"/>
+                <c:pt idx="0">
+                  <c:v>Low</c:v>
+                </c:pt>
+              </c:strCache>
+            </c:strRef>
+          </c:tx>
+          <c:spPr>
+            <a:solidFill>
+              <a:srgbClr val="929194"/>
+            </a:solidFill>
+            <a:ln w="31750" cap="flat">
+              <a:solidFill>
+                <a:srgbClr val="929194"/>
+              </a:solidFill>
+              <a:prstDash val="solid"/>
+              <a:round/>
+            </a:ln>
+            <a:effectLst/>
+          </c:spPr>
+          <c:invertIfNegative val="0"/>
+          <c:dLbls>
+            <c:numFmt formatCode="#,##0" sourceLinked="0"/>
+            <c:txPr>
+              <a:bodyPr/>
+              <a:lstStyle/>
+              <a:p>
+                <a:pPr>
+                  <a:defRPr b="0" i="0" strike="noStrike" sz="1100" u="none">
+                    <a:solidFill>
+                      <a:srgbClr val="2C2F33"/>
+                    </a:solidFill>
+                    <a:latin typeface="Arial"/>
+                  </a:defRPr>
+                </a:pPr>
+              </a:p>
+            </c:txPr>
+            <c:showLegendKey val="0"/>
+            <c:showVal val="0"/>
+            <c:showCatName val="0"/>
+            <c:showSerName val="0"/>
+            <c:showPercent val="0"/>
+            <c:showBubbleSize val="0"/>
+            <c:showLeaderLines val="0"/>
+          </c:dLbls>
+          <c:marker>
+            <c:symbol val="circle"/>
+            <c:size val="7"/>
+            <c:spPr>
+              <a:solidFill>
+                <a:srgbClr val="929194"/>
+              </a:solidFill>
+              <a:ln w="9525" cap="flat">
+                <a:solidFill>
+                  <a:srgbClr val="929194"/>
+                </a:solidFill>
+                <a:prstDash val="solid"/>
+                <a:round/>
+              </a:ln>
+              <a:effectLst/>
+            </c:spPr>
+          </c:marker>
+          <c:cat>
+            <c:multiLvlStrRef>
+              <c:f>Sheet1!$A$2:$A$6</c:f>
+              <c:multiLvlStrCache>
+                <c:ptCount val="5"/>
+                <c:lvl>
+                  <c:pt idx="0">
+                    <c:v>Today</c:v>
+                  </c:pt>
+                  <c:pt idx="1">
+                    <c:v>Month 3</c:v>
+                  </c:pt>
+                  <c:pt idx="2">
+                    <c:v>Month 6</c:v>
+                  </c:pt>
+                  <c:pt idx="3">
+                    <c:v>Month 9</c:v>
+                  </c:pt>
+                  <c:pt idx="4">
+                    <c:v>Month 12</c:v>
+                  </c:pt>
+                </c:lvl>
+              </c:multiLvlStrCache>
+            </c:multiLvlStrRef>
+          </c:cat>
+          <c:val>
+            <c:numRef>
+              <c:f>Sheet1!$D$2:$D$6</c:f>
+              <c:numCache>
+                <c:formatCode>General</c:formatCode>
+                <c:ptCount val="5"/>
+                <c:pt idx="0">
+                  <c:v>100</c:v>
+                </c:pt>
+                <c:pt idx="1">
+                  <c:v>108</c:v>
+                </c:pt>
+                <c:pt idx="2">
+                  <c:v>125</c:v>
+                </c:pt>
+                <c:pt idx="3">
+                  <c:v>140</c:v>
+                </c:pt>
+                <c:pt idx="4">
+                  <c:v>154</c:v>
+                </c:pt>
+              </c:numCache>
+            </c:numRef>
+          </c:val>
+          <c:smooth val="0"/>
+        </c:ser>
         <c:dLbls>
-          <c:numFmt formatCode="0" sourceLinked="0"/>
+          <c:numFmt formatCode="#,##0" sourceLinked="0"/>
           <c:txPr>
             <a:bodyPr/>
             <a:lstStyle/>
@@ -2375,9 +2872,8 @@
               </a:pPr>
             </a:p>
           </c:txPr>
-          <c:dLblPos val="t"/>
           <c:showLegendKey val="0"/>
-          <c:showVal val="1"/>
+          <c:showVal val="0"/>
           <c:showCatName val="0"/>
           <c:showSerName val="0"/>
           <c:showPercent val="0"/>
@@ -2434,7 +2930,7 @@
         <c:axId val="2094734552"/>
         <c:scaling>
           <c:orientation val="minMax"/>
-          <c:max val="260"/>
+          <c:max val="350"/>
           <c:min val="0"/>
         </c:scaling>
         <c:delete val="0"/>
@@ -2488,6 +2984,26 @@
         <a:effectLst/>
       </c:spPr>
     </c:plotArea>
+    <c:legend>
+      <c:legendPos val="b"/>
+      <c:overlay val="0"/>
+      <c:txPr>
+        <a:bodyPr/>
+        <a:lstStyle/>
+        <a:p>
+          <a:pPr>
+            <a:defRPr sz="1000">
+              <a:solidFill>
+                <a:srgbClr val="2C2F33"/>
+              </a:solidFill>
+              <a:latin typeface="Arial"/>
+              <a:cs typeface="Arial"/>
+            </a:defRPr>
+          </a:pPr>
+          <a:endParaRPr lang="en-US"/>
+        </a:p>
+      </c:txPr>
+    </c:legend>
     <c:plotVisOnly val="1"/>
     <c:dispBlanksAs val="span"/>
   </c:chart>
@@ -6802,7 +7318,7 @@
                 <a:ea typeface="Arial" pitchFamily="34" charset="-122"/>
                 <a:cs typeface="Arial" pitchFamily="34" charset="-120"/>
               </a:rPr>
-              <a:t>By month 12: about twice the leads from search, and traffic back to roughly 117K. Not 140K, and here is why.</a:t>
+              <a:t>By month 12: leads roughly double in the base case, and traffic lands between about 100K and 135K. 140K sits above our stretch case.</a:t>
             </a:r>
             <a:endParaRPr lang="en-US" sz="2600" dirty="0"/>
           </a:p>
@@ -6933,7 +7449,7 @@
                 <a:ea typeface="Arial" pitchFamily="34" charset="-122"/>
                 <a:cs typeface="Arial" pitchFamily="34" charset="-120"/>
               </a:rPr>
-              <a:t>Projection, not a forecast. Every assumption is listed in the working model and gets replaced with measured numbers at day 90.</a:t>
+              <a:t>Three scenarios, not a forecast. The base case assumes the top-page sample's mix holds for the whole site; week-one Search Console data replaces that assumption.</a:t>
             </a:r>
             <a:endParaRPr lang="en-US" sz="850" dirty="0"/>
           </a:p>
@@ -7004,7 +7520,7 @@
                 <a:ea typeface="Arial" pitchFamily="34" charset="-122"/>
                 <a:cs typeface="Arial" pitchFamily="34" charset="-120"/>
               </a:rPr>
-              <a:t>Why not 140K: your biggest searches now have an AI answer on top, and the two expired pages were queries that government sites now own. The old pages top out near 117K even if every refresh works. Anything above that comes from new comparison pages and templates. We would rather tell you this now than explain it in month 12.</a:t>
+              <a:t>Month 12, base case: about 117,000 visits and 2.2x leads. Low: 101,000 and 1.5x. Stretch: 136,000 and 3x. Why even the stretch case stays under 140K: your biggest searches now have an AI answer on top, and the two expired pages were queries that government sites now own. Growth beyond the base case comes from new comparison pages and templates, not from the old pages returning to their old numbers.</a:t>
             </a:r>
             <a:endParaRPr lang="en-US" sz="1100" dirty="0"/>
           </a:p>
@@ -7093,7 +7609,7 @@
                 <a:ea typeface="Arial" pitchFamily="34" charset="-122"/>
                 <a:cs typeface="Arial" pitchFamily="34" charset="-120"/>
               </a:rPr>
-              <a:t>The traffic line recovers. The leads line is the one we are accountable for, and it moves faster because the first fixes land on the pages that convert.</a:t>
+              <a:t>The traffic line recovers in every case. The leads line is the one we are accountable for, and it moves faster because the first fixes land on the pages that convert.</a:t>
             </a:r>
             <a:endParaRPr lang="en-US" sz="1300" dirty="0"/>
           </a:p>

</xml_diff>

<commit_message>
Option B content model (client voice skill, AI drafting, editor as validation layer, saving to links); PDF back to 4 pages
Co-Authored-By: Claude Fable 5.1 <noreply@anthropic.com>
Claude-Session: https://claude.ai/code/session_015LEzkrfcXznaX9ERkNGL27
</commit_message>
<xml_diff>
--- a/deck/SEO_recovery_plan_client_deck.pptx
+++ b/deck/SEO_recovery_plan_client_deck.pptx
@@ -20,9 +20,10 @@
     <p:sldId id="268" r:id="rId14"/>
     <p:sldId id="269" r:id="rId15"/>
     <p:sldId id="270" r:id="rId16"/>
+    <p:sldId id="271" r:id="rId17"/>
   </p:sldIdLst>
   <p:notesMasterIdLst>
-    <p:notesMasterId r:id="rId17"/>
+    <p:notesMasterId r:id="rId18"/>
   </p:notesMasterIdLst>
   <p:sldSz cx="12192000" cy="6858000"/>
   <p:notesSz cx="6858000" cy="12192000"/>
@@ -3967,6 +3968,94 @@
             <a:fld id="{F7021451-1387-4CA6-816F-3879F97B5CBC}" type="slidenum">
               <a:rPr lang="en-US"/>
               <a:t>15</a:t>
+            </a:fld>
+            <a:endParaRPr lang="en-US"/>
+          </a:p>
+        </p:txBody>
+      </p:sp>
+    </p:spTree>
+    <p:extLst>
+      <p:ext uri="{BB962C8B-B14F-4D97-AF65-F5344CB8AC3E}">
+        <p14:creationId xmlns:p14="http://schemas.microsoft.com/office/powerpoint/2010/main" val="1024086991"/>
+      </p:ext>
+    </p:extLst>
+  </p:cSld>
+  <p:clrMapOvr>
+    <a:masterClrMapping/>
+  </p:clrMapOvr>
+</p:notes>
+</file>
+
+<file path=ppt/notesSlides/notesSlide16.xml><?xml version="1.0" encoding="utf-8"?>
+<p:notes xmlns:a="http://schemas.openxmlformats.org/drawingml/2006/main" xmlns:r="http://schemas.openxmlformats.org/officeDocument/2006/relationships" xmlns:p="http://schemas.openxmlformats.org/presentationml/2006/main">
+  <p:cSld>
+    <p:spTree>
+      <p:nvGrpSpPr>
+        <p:cNvPr id="1" name=""/>
+        <p:cNvGrpSpPr/>
+        <p:nvPr/>
+      </p:nvGrpSpPr>
+      <p:grpSpPr>
+        <a:xfrm>
+          <a:off x="0" y="0"/>
+          <a:ext cx="0" cy="0"/>
+          <a:chOff x="0" y="0"/>
+          <a:chExt cx="0" cy="0"/>
+        </a:xfrm>
+      </p:grpSpPr>
+      <p:sp>
+        <p:nvSpPr>
+          <p:cNvPr id="2" name="Slide Image Placeholder 1"/>
+          <p:cNvSpPr>
+            <a:spLocks noGrp="1" noRot="1" noChangeAspect="1"/>
+          </p:cNvSpPr>
+          <p:nvPr>
+            <p:ph type="sldImg"/>
+          </p:nvPr>
+        </p:nvSpPr>
+        <p:spPr/>
+      </p:sp>
+      <p:sp>
+        <p:nvSpPr>
+          <p:cNvPr id="3" name="Notes Placeholder 2"/>
+          <p:cNvSpPr>
+            <a:spLocks noGrp="1"/>
+          </p:cNvSpPr>
+          <p:nvPr>
+            <p:ph type="body" idx="1"/>
+          </p:nvPr>
+        </p:nvSpPr>
+        <p:spPr/>
+        <p:txBody>
+          <a:bodyPr/>
+          <a:lstStyle/>
+          <a:p>
+            <a:r>
+              <a:rPr lang="en-US" dirty="0"/>
+              <a:t/>
+            </a:r>
+            <a:endParaRPr lang="en-US" dirty="0"/>
+          </a:p>
+        </p:txBody>
+      </p:sp>
+      <p:sp>
+        <p:nvSpPr>
+          <p:cNvPr id="4" name="Slide Number Placeholder 3"/>
+          <p:cNvSpPr>
+            <a:spLocks noGrp="1"/>
+          </p:cNvSpPr>
+          <p:nvPr>
+            <p:ph type="sldNum" sz="quarter" idx="10"/>
+          </p:nvPr>
+        </p:nvSpPr>
+        <p:spPr/>
+        <p:txBody>
+          <a:bodyPr/>
+          <a:lstStyle/>
+          <a:p>
+            <a:fld id="{F7021451-1387-4CA6-816F-3879F97B5CBC}" type="slidenum">
+              <a:rPr lang="en-US"/>
+              <a:t>16</a:t>
             </a:fld>
             <a:endParaRPr lang="en-US"/>
           </a:p>
@@ -6231,7 +6320,7 @@
                 <a:ea typeface="Arial" pitchFamily="34" charset="-122"/>
                 <a:cs typeface="Arial" pitchFamily="34" charset="-120"/>
               </a:rPr>
-              <a:t>THE COMPETITION</a:t>
+              <a:t>AN ALTERNATIVE FOR PRODUCING THE CONTENT</a:t>
             </a:r>
             <a:endParaRPr lang="en-US" sz="1100" dirty="0"/>
           </a:p>
@@ -6270,7 +6359,7 @@
                 <a:ea typeface="Arial" pitchFamily="34" charset="-122"/>
                 <a:cs typeface="Arial" pitchFamily="34" charset="-120"/>
               </a:rPr>
-              <a:t>We will not out-publish Ramp. We win where they do not play.</a:t>
+              <a:t>Option B: draft in your voice with AI, check every piece with an editor, and spend the saving on links.</a:t>
             </a:r>
             <a:endParaRPr lang="en-US" sz="2600" dirty="0"/>
           </a:p>
@@ -6401,7 +6490,7 @@
                 <a:ea typeface="Arial" pitchFamily="34" charset="-122"/>
                 <a:cs typeface="Arial" pitchFamily="34" charset="-120"/>
               </a:rPr>
-              <a:t>Source: Ramp's publishing pace from your brief; linking sites gained per month from a public backlink index, 12 months to September 2026</a:t>
+              <a:t>Costs are assumptions, marked as such in the budget sheet. Testable in Q2 against the same holdout.</a:t>
             </a:r>
             <a:endParaRPr lang="en-US" sz="850" dirty="0"/>
           </a:p>
@@ -6416,7 +6505,7 @@
         <p:spPr>
           <a:xfrm>
             <a:off x="548640" y="1828800"/>
-            <a:ext cx="3566160" cy="1188720"/>
+            <a:ext cx="5394960" cy="2194560"/>
           </a:xfrm>
           <a:prstGeom prst="rect">
             <a:avLst/>
@@ -6434,14 +6523,39 @@
       </p:sp>
       <p:sp>
         <p:nvSpPr>
-          <p:cNvPr id="9" name="Text 7"/>
-          <p:cNvSpPr/>
-          <p:nvPr/>
-        </p:nvSpPr>
-        <p:spPr>
-          <a:xfrm>
-            <a:off x="731520" y="1938528"/>
-            <a:ext cx="3200400" cy="594360"/>
+          <p:cNvPr id="9" name="Shape 7"/>
+          <p:cNvSpPr/>
+          <p:nvPr/>
+        </p:nvSpPr>
+        <p:spPr>
+          <a:xfrm>
+            <a:off x="548640" y="1828800"/>
+            <a:ext cx="5394960" cy="73152"/>
+          </a:xfrm>
+          <a:prstGeom prst="rect">
+            <a:avLst/>
+          </a:prstGeom>
+          <a:solidFill>
+            <a:srgbClr val="2F343A"/>
+          </a:solidFill>
+          <a:ln w="12700">
+            <a:solidFill>
+              <a:srgbClr val="2F343A"/>
+            </a:solidFill>
+            <a:prstDash val="solid"/>
+          </a:ln>
+        </p:spPr>
+      </p:sp>
+      <p:sp>
+        <p:nvSpPr>
+          <p:cNvPr id="10" name="Text 8"/>
+          <p:cNvSpPr/>
+          <p:nvPr/>
+        </p:nvSpPr>
+        <p:spPr>
+          <a:xfrm>
+            <a:off x="749808" y="2011680"/>
+            <a:ext cx="4992624" cy="457200"/>
           </a:xfrm>
           <a:prstGeom prst="rect">
             <a:avLst/>
@@ -6450,37 +6564,37 @@
           <a:ln/>
         </p:spPr>
         <p:txBody>
-          <a:bodyPr wrap="square" lIns="0" tIns="0" rIns="0" bIns="0" rtlCol="0" anchor="ctr"/>
-          <a:lstStyle/>
-          <a:p>
-            <a:pPr indent="0" marL="0">
-              <a:buNone/>
-            </a:pPr>
-            <a:r>
-              <a:rPr lang="en-US" sz="3000" b="1" dirty="0">
-                <a:solidFill>
-                  <a:srgbClr val="F27038"/>
-                </a:solidFill>
-                <a:latin typeface="Arial" pitchFamily="34" charset="0"/>
-                <a:ea typeface="Arial" pitchFamily="34" charset="-122"/>
-                <a:cs typeface="Arial" pitchFamily="34" charset="-120"/>
-              </a:rPr>
-              <a:t>100 vs 48</a:t>
-            </a:r>
-            <a:endParaRPr lang="en-US" sz="3000" dirty="0"/>
-          </a:p>
-        </p:txBody>
-      </p:sp>
-      <p:sp>
-        <p:nvSpPr>
-          <p:cNvPr id="10" name="Text 8"/>
-          <p:cNvSpPr/>
-          <p:nvPr/>
-        </p:nvSpPr>
-        <p:spPr>
-          <a:xfrm>
-            <a:off x="731520" y="2482596"/>
-            <a:ext cx="3200400" cy="475488"/>
+          <a:bodyPr wrap="square" lIns="0" tIns="0" rIns="0" bIns="0" rtlCol="0" anchor="t"/>
+          <a:lstStyle/>
+          <a:p>
+            <a:pPr indent="0" marL="0">
+              <a:buNone/>
+            </a:pPr>
+            <a:r>
+              <a:rPr lang="en-US" sz="1500" b="1" dirty="0">
+                <a:solidFill>
+                  <a:srgbClr val="2F343A"/>
+                </a:solidFill>
+                <a:latin typeface="Arial" pitchFamily="34" charset="0"/>
+                <a:ea typeface="Arial" pitchFamily="34" charset="-122"/>
+                <a:cs typeface="Arial" pitchFamily="34" charset="-120"/>
+              </a:rPr>
+              <a:t>Option A: three freelance writers</a:t>
+            </a:r>
+            <a:endParaRPr lang="en-US" sz="1500" dirty="0"/>
+          </a:p>
+        </p:txBody>
+      </p:sp>
+      <p:sp>
+        <p:nvSpPr>
+          <p:cNvPr id="11" name="Text 9"/>
+          <p:cNvSpPr/>
+          <p:nvPr/>
+        </p:nvSpPr>
+        <p:spPr>
+          <a:xfrm>
+            <a:off x="749808" y="2606040"/>
+            <a:ext cx="4992624" cy="1298448"/>
           </a:xfrm>
           <a:prstGeom prst="rect">
             <a:avLst/>
@@ -6504,7 +6618,7 @@
                 <a:ea typeface="Arial" pitchFamily="34" charset="-122"/>
                 <a:cs typeface="Arial" pitchFamily="34" charset="-120"/>
               </a:rPr>
-              <a:t>posts a year: Ramp's pace against yours</a:t>
+              <a:t>4 new posts and 8 refreshes a month, written by freelancers from briefs. About $2,800 a month. Known quantity, slower, and every writer brings their own voice.</a:t>
             </a:r>
             <a:endParaRPr lang="en-US" sz="1150" dirty="0"/>
           </a:p>
@@ -6512,14 +6626,14 @@
       </p:sp>
       <p:sp>
         <p:nvSpPr>
-          <p:cNvPr id="11" name="Shape 9"/>
-          <p:cNvSpPr/>
-          <p:nvPr/>
-        </p:nvSpPr>
-        <p:spPr>
-          <a:xfrm>
-            <a:off x="4297680" y="1828800"/>
-            <a:ext cx="3566160" cy="1188720"/>
+          <p:cNvPr id="12" name="Shape 10"/>
+          <p:cNvSpPr/>
+          <p:nvPr/>
+        </p:nvSpPr>
+        <p:spPr>
+          <a:xfrm>
+            <a:off x="6217920" y="1828800"/>
+            <a:ext cx="5394960" cy="2194560"/>
           </a:xfrm>
           <a:prstGeom prst="rect">
             <a:avLst/>
@@ -6537,14 +6651,39 @@
       </p:sp>
       <p:sp>
         <p:nvSpPr>
-          <p:cNvPr id="12" name="Text 10"/>
-          <p:cNvSpPr/>
-          <p:nvPr/>
-        </p:nvSpPr>
-        <p:spPr>
-          <a:xfrm>
-            <a:off x="4480560" y="1938528"/>
-            <a:ext cx="3200400" cy="594360"/>
+          <p:cNvPr id="13" name="Shape 11"/>
+          <p:cNvSpPr/>
+          <p:nvPr/>
+        </p:nvSpPr>
+        <p:spPr>
+          <a:xfrm>
+            <a:off x="6217920" y="1828800"/>
+            <a:ext cx="5394960" cy="73152"/>
+          </a:xfrm>
+          <a:prstGeom prst="rect">
+            <a:avLst/>
+          </a:prstGeom>
+          <a:solidFill>
+            <a:srgbClr val="F27038"/>
+          </a:solidFill>
+          <a:ln w="12700">
+            <a:solidFill>
+              <a:srgbClr val="F27038"/>
+            </a:solidFill>
+            <a:prstDash val="solid"/>
+          </a:ln>
+        </p:spPr>
+      </p:sp>
+      <p:sp>
+        <p:nvSpPr>
+          <p:cNvPr id="14" name="Text 12"/>
+          <p:cNvSpPr/>
+          <p:nvPr/>
+        </p:nvSpPr>
+        <p:spPr>
+          <a:xfrm>
+            <a:off x="6419088" y="2011680"/>
+            <a:ext cx="4992624" cy="457200"/>
           </a:xfrm>
           <a:prstGeom prst="rect">
             <a:avLst/>
@@ -6553,37 +6692,37 @@
           <a:ln/>
         </p:spPr>
         <p:txBody>
-          <a:bodyPr wrap="square" lIns="0" tIns="0" rIns="0" bIns="0" rtlCol="0" anchor="ctr"/>
-          <a:lstStyle/>
-          <a:p>
-            <a:pPr indent="0" marL="0">
-              <a:buNone/>
-            </a:pPr>
-            <a:r>
-              <a:rPr lang="en-US" sz="3000" b="1" dirty="0">
-                <a:solidFill>
-                  <a:srgbClr val="F27038"/>
-                </a:solidFill>
-                <a:latin typeface="Arial" pitchFamily="34" charset="0"/>
-                <a:ea typeface="Arial" pitchFamily="34" charset="-122"/>
-                <a:cs typeface="Arial" pitchFamily="34" charset="-120"/>
-              </a:rPr>
-              <a:t>340</a:t>
-            </a:r>
-            <a:endParaRPr lang="en-US" sz="3000" dirty="0"/>
-          </a:p>
-        </p:txBody>
-      </p:sp>
-      <p:sp>
-        <p:nvSpPr>
-          <p:cNvPr id="13" name="Text 11"/>
-          <p:cNvSpPr/>
-          <p:nvPr/>
-        </p:nvSpPr>
-        <p:spPr>
-          <a:xfrm>
-            <a:off x="4480560" y="2482596"/>
-            <a:ext cx="3200400" cy="475488"/>
+          <a:bodyPr wrap="square" lIns="0" tIns="0" rIns="0" bIns="0" rtlCol="0" anchor="t"/>
+          <a:lstStyle/>
+          <a:p>
+            <a:pPr indent="0" marL="0">
+              <a:buNone/>
+            </a:pPr>
+            <a:r>
+              <a:rPr lang="en-US" sz="1500" b="1" dirty="0">
+                <a:solidFill>
+                  <a:srgbClr val="2F343A"/>
+                </a:solidFill>
+                <a:latin typeface="Arial" pitchFamily="34" charset="0"/>
+                <a:ea typeface="Arial" pitchFamily="34" charset="-122"/>
+                <a:cs typeface="Arial" pitchFamily="34" charset="-120"/>
+              </a:rPr>
+              <a:t>Option B: your voice, drafted faster, edited by a person</a:t>
+            </a:r>
+            <a:endParaRPr lang="en-US" sz="1500" dirty="0"/>
+          </a:p>
+        </p:txBody>
+      </p:sp>
+      <p:sp>
+        <p:nvSpPr>
+          <p:cNvPr id="15" name="Text 13"/>
+          <p:cNvSpPr/>
+          <p:nvPr/>
+        </p:nvSpPr>
+        <p:spPr>
+          <a:xfrm>
+            <a:off x="6419088" y="2606040"/>
+            <a:ext cx="4992624" cy="1298448"/>
           </a:xfrm>
           <a:prstGeom prst="rect">
             <a:avLst/>
@@ -6607,7 +6746,7 @@
                 <a:ea typeface="Arial" pitchFamily="34" charset="-122"/>
                 <a:cs typeface="Arial" pitchFamily="34" charset="-120"/>
               </a:rPr>
-              <a:t>new websites linking to Ramp every month</a:t>
+              <a:t>We interview your Content Manager and two subject experts on tone, style and how you talk to customers, and build a dedicated writing setup from that. It drafts from the same briefs. A freelance editor checks facts, sources, voice and the call to action on every piece before anything publishes. About $1,200 a month plus a one-off $1,500 setup.</a:t>
             </a:r>
             <a:endParaRPr lang="en-US" sz="1150" dirty="0"/>
           </a:p>
@@ -6615,14 +6754,220 @@
       </p:sp>
       <p:sp>
         <p:nvSpPr>
-          <p:cNvPr id="14" name="Shape 12"/>
-          <p:cNvSpPr/>
-          <p:nvPr/>
-        </p:nvSpPr>
-        <p:spPr>
-          <a:xfrm>
-            <a:off x="8046720" y="1828800"/>
-            <a:ext cx="3566160" cy="1188720"/>
+          <p:cNvPr id="16" name="Shape 14"/>
+          <p:cNvSpPr/>
+          <p:nvPr/>
+        </p:nvSpPr>
+        <p:spPr>
+          <a:xfrm>
+            <a:off x="548640" y="4206240"/>
+            <a:ext cx="3566160" cy="1234440"/>
+          </a:xfrm>
+          <a:prstGeom prst="rect">
+            <a:avLst/>
+          </a:prstGeom>
+          <a:solidFill>
+            <a:srgbClr val="F8F8F8"/>
+          </a:solidFill>
+          <a:ln w="12700">
+            <a:solidFill>
+              <a:srgbClr val="E9EFF4"/>
+            </a:solidFill>
+            <a:prstDash val="solid"/>
+          </a:ln>
+        </p:spPr>
+      </p:sp>
+      <p:sp>
+        <p:nvSpPr>
+          <p:cNvPr id="17" name="Text 15"/>
+          <p:cNvSpPr/>
+          <p:nvPr/>
+        </p:nvSpPr>
+        <p:spPr>
+          <a:xfrm>
+            <a:off x="731520" y="4315968"/>
+            <a:ext cx="3200400" cy="617220"/>
+          </a:xfrm>
+          <a:prstGeom prst="rect">
+            <a:avLst/>
+          </a:prstGeom>
+          <a:noFill/>
+          <a:ln/>
+        </p:spPr>
+        <p:txBody>
+          <a:bodyPr wrap="square" lIns="0" tIns="0" rIns="0" bIns="0" rtlCol="0" anchor="ctr"/>
+          <a:lstStyle/>
+          <a:p>
+            <a:pPr indent="0" marL="0">
+              <a:buNone/>
+            </a:pPr>
+            <a:r>
+              <a:rPr lang="en-US" sz="3000" b="1" dirty="0">
+                <a:solidFill>
+                  <a:srgbClr val="F27038"/>
+                </a:solidFill>
+                <a:latin typeface="Arial" pitchFamily="34" charset="0"/>
+                <a:ea typeface="Arial" pitchFamily="34" charset="-122"/>
+                <a:cs typeface="Arial" pitchFamily="34" charset="-120"/>
+              </a:rPr>
+              <a:t>$1,600</a:t>
+            </a:r>
+            <a:endParaRPr lang="en-US" sz="3000" dirty="0"/>
+          </a:p>
+        </p:txBody>
+      </p:sp>
+      <p:sp>
+        <p:nvSpPr>
+          <p:cNvPr id="18" name="Text 16"/>
+          <p:cNvSpPr/>
+          <p:nvPr/>
+        </p:nvSpPr>
+        <p:spPr>
+          <a:xfrm>
+            <a:off x="731520" y="4885182"/>
+            <a:ext cx="3200400" cy="493776"/>
+          </a:xfrm>
+          <a:prstGeom prst="rect">
+            <a:avLst/>
+          </a:prstGeom>
+          <a:noFill/>
+          <a:ln/>
+        </p:spPr>
+        <p:txBody>
+          <a:bodyPr wrap="square" lIns="0" tIns="0" rIns="0" bIns="0" rtlCol="0" anchor="t"/>
+          <a:lstStyle/>
+          <a:p>
+            <a:pPr indent="0" marL="0">
+              <a:buNone/>
+            </a:pPr>
+            <a:r>
+              <a:rPr lang="en-US" sz="1150" dirty="0">
+                <a:solidFill>
+                  <a:srgbClr val="2C2F33"/>
+                </a:solidFill>
+                <a:latin typeface="Arial" pitchFamily="34" charset="0"/>
+                <a:ea typeface="Arial" pitchFamily="34" charset="-122"/>
+                <a:cs typeface="Arial" pitchFamily="34" charset="-120"/>
+              </a:rPr>
+              <a:t>a month moves from writing to earning links</a:t>
+            </a:r>
+            <a:endParaRPr lang="en-US" sz="1150" dirty="0"/>
+          </a:p>
+        </p:txBody>
+      </p:sp>
+      <p:sp>
+        <p:nvSpPr>
+          <p:cNvPr id="19" name="Shape 17"/>
+          <p:cNvSpPr/>
+          <p:nvPr/>
+        </p:nvSpPr>
+        <p:spPr>
+          <a:xfrm>
+            <a:off x="4297680" y="4206240"/>
+            <a:ext cx="3566160" cy="1234440"/>
+          </a:xfrm>
+          <a:prstGeom prst="rect">
+            <a:avLst/>
+          </a:prstGeom>
+          <a:solidFill>
+            <a:srgbClr val="F8F8F8"/>
+          </a:solidFill>
+          <a:ln w="12700">
+            <a:solidFill>
+              <a:srgbClr val="E9EFF4"/>
+            </a:solidFill>
+            <a:prstDash val="solid"/>
+          </a:ln>
+        </p:spPr>
+      </p:sp>
+      <p:sp>
+        <p:nvSpPr>
+          <p:cNvPr id="20" name="Text 18"/>
+          <p:cNvSpPr/>
+          <p:nvPr/>
+        </p:nvSpPr>
+        <p:spPr>
+          <a:xfrm>
+            <a:off x="4480560" y="4315968"/>
+            <a:ext cx="3200400" cy="617220"/>
+          </a:xfrm>
+          <a:prstGeom prst="rect">
+            <a:avLst/>
+          </a:prstGeom>
+          <a:noFill/>
+          <a:ln/>
+        </p:spPr>
+        <p:txBody>
+          <a:bodyPr wrap="square" lIns="0" tIns="0" rIns="0" bIns="0" rtlCol="0" anchor="ctr"/>
+          <a:lstStyle/>
+          <a:p>
+            <a:pPr indent="0" marL="0">
+              <a:buNone/>
+            </a:pPr>
+            <a:r>
+              <a:rPr lang="en-US" sz="3000" b="1" dirty="0">
+                <a:solidFill>
+                  <a:srgbClr val="F27038"/>
+                </a:solidFill>
+                <a:latin typeface="Arial" pitchFamily="34" charset="0"/>
+                <a:ea typeface="Arial" pitchFamily="34" charset="-122"/>
+                <a:cs typeface="Arial" pitchFamily="34" charset="-120"/>
+              </a:rPr>
+              <a:t>12 to 20</a:t>
+            </a:r>
+            <a:endParaRPr lang="en-US" sz="3000" dirty="0"/>
+          </a:p>
+        </p:txBody>
+      </p:sp>
+      <p:sp>
+        <p:nvSpPr>
+          <p:cNvPr id="21" name="Text 19"/>
+          <p:cNvSpPr/>
+          <p:nvPr/>
+        </p:nvSpPr>
+        <p:spPr>
+          <a:xfrm>
+            <a:off x="4480560" y="4885182"/>
+            <a:ext cx="3200400" cy="493776"/>
+          </a:xfrm>
+          <a:prstGeom prst="rect">
+            <a:avLst/>
+          </a:prstGeom>
+          <a:noFill/>
+          <a:ln/>
+        </p:spPr>
+        <p:txBody>
+          <a:bodyPr wrap="square" lIns="0" tIns="0" rIns="0" bIns="0" rtlCol="0" anchor="t"/>
+          <a:lstStyle/>
+          <a:p>
+            <a:pPr indent="0" marL="0">
+              <a:buNone/>
+            </a:pPr>
+            <a:r>
+              <a:rPr lang="en-US" sz="1150" dirty="0">
+                <a:solidFill>
+                  <a:srgbClr val="2C2F33"/>
+                </a:solidFill>
+                <a:latin typeface="Arial" pitchFamily="34" charset="0"/>
+                <a:ea typeface="Arial" pitchFamily="34" charset="-122"/>
+                <a:cs typeface="Arial" pitchFamily="34" charset="-120"/>
+              </a:rPr>
+              <a:t>relevant link placements a month instead of 6 to 10</a:t>
+            </a:r>
+            <a:endParaRPr lang="en-US" sz="1150" dirty="0"/>
+          </a:p>
+        </p:txBody>
+      </p:sp>
+      <p:sp>
+        <p:nvSpPr>
+          <p:cNvPr id="22" name="Shape 20"/>
+          <p:cNvSpPr/>
+          <p:nvPr/>
+        </p:nvSpPr>
+        <p:spPr>
+          <a:xfrm>
+            <a:off x="8046720" y="4206240"/>
+            <a:ext cx="3566160" cy="1234440"/>
           </a:xfrm>
           <a:prstGeom prst="rect">
             <a:avLst/>
@@ -6640,14 +6985,14 @@
       </p:sp>
       <p:sp>
         <p:nvSpPr>
-          <p:cNvPr id="15" name="Text 13"/>
-          <p:cNvSpPr/>
-          <p:nvPr/>
-        </p:nvSpPr>
-        <p:spPr>
-          <a:xfrm>
-            <a:off x="8229600" y="1938528"/>
-            <a:ext cx="3200400" cy="594360"/>
+          <p:cNvPr id="23" name="Text 21"/>
+          <p:cNvSpPr/>
+          <p:nvPr/>
+        </p:nvSpPr>
+        <p:spPr>
+          <a:xfrm>
+            <a:off x="8229600" y="4315968"/>
+            <a:ext cx="3200400" cy="617220"/>
           </a:xfrm>
           <a:prstGeom prst="rect">
             <a:avLst/>
@@ -6671,7 +7016,7 @@
                 <a:ea typeface="Arial" pitchFamily="34" charset="-122"/>
                 <a:cs typeface="Arial" pitchFamily="34" charset="-120"/>
               </a:rPr>
-              <a:t>5x</a:t>
+              <a:t>Q2 test</a:t>
             </a:r>
             <a:endParaRPr lang="en-US" sz="3000" dirty="0"/>
           </a:p>
@@ -6679,14 +7024,14 @@
       </p:sp>
       <p:sp>
         <p:nvSpPr>
-          <p:cNvPr id="16" name="Text 14"/>
-          <p:cNvSpPr/>
-          <p:nvPr/>
-        </p:nvSpPr>
-        <p:spPr>
-          <a:xfrm>
-            <a:off x="8229600" y="2482596"/>
-            <a:ext cx="3200400" cy="475488"/>
+          <p:cNvPr id="24" name="Text 22"/>
+          <p:cNvSpPr/>
+          <p:nvPr/>
+        </p:nvSpPr>
+        <p:spPr>
+          <a:xfrm>
+            <a:off x="8229600" y="4885182"/>
+            <a:ext cx="3200400" cy="493776"/>
           </a:xfrm>
           <a:prstGeom prst="rect">
             <a:avLst/>
@@ -6710,7 +7055,7 @@
                 <a:ea typeface="Arial" pitchFamily="34" charset="-122"/>
                 <a:cs typeface="Arial" pitchFamily="34" charset="-120"/>
               </a:rPr>
-              <a:t>your traffic. Ramp is a much bigger site</a:t>
+              <a:t>half the refreshes each way, measured against the holdout</a:t>
             </a:r>
             <a:endParaRPr lang="en-US" sz="1150" dirty="0"/>
           </a:p>
@@ -6718,20 +7063,20 @@
       </p:sp>
       <p:sp>
         <p:nvSpPr>
-          <p:cNvPr id="17" name="Shape 15"/>
-          <p:cNvSpPr/>
-          <p:nvPr/>
-        </p:nvSpPr>
-        <p:spPr>
-          <a:xfrm>
-            <a:off x="548640" y="3200400"/>
-            <a:ext cx="3566160" cy="2286000"/>
+          <p:cNvPr id="25" name="Shape 23"/>
+          <p:cNvSpPr/>
+          <p:nvPr/>
+        </p:nvSpPr>
+        <p:spPr>
+          <a:xfrm>
+            <a:off x="548640" y="5623560"/>
+            <a:ext cx="11064240" cy="566928"/>
           </a:xfrm>
           <a:prstGeom prst="rect">
             <a:avLst/>
           </a:prstGeom>
           <a:solidFill>
-            <a:srgbClr val="F8F8F8"/>
+            <a:srgbClr val="E9EFF4"/>
           </a:solidFill>
           <a:ln w="12700">
             <a:solidFill>
@@ -6743,14 +7088,14 @@
       </p:sp>
       <p:sp>
         <p:nvSpPr>
-          <p:cNvPr id="18" name="Shape 16"/>
-          <p:cNvSpPr/>
-          <p:nvPr/>
-        </p:nvSpPr>
-        <p:spPr>
-          <a:xfrm>
-            <a:off x="548640" y="3200400"/>
-            <a:ext cx="3566160" cy="73152"/>
+          <p:cNvPr id="26" name="Shape 24"/>
+          <p:cNvSpPr/>
+          <p:nvPr/>
+        </p:nvSpPr>
+        <p:spPr>
+          <a:xfrm>
+            <a:off x="548640" y="5623560"/>
+            <a:ext cx="82296" cy="566928"/>
           </a:xfrm>
           <a:prstGeom prst="rect">
             <a:avLst/>
@@ -6768,14 +7113,14 @@
       </p:sp>
       <p:sp>
         <p:nvSpPr>
-          <p:cNvPr id="19" name="Text 17"/>
-          <p:cNvSpPr/>
-          <p:nvPr/>
-        </p:nvSpPr>
-        <p:spPr>
-          <a:xfrm>
-            <a:off x="749808" y="3383280"/>
-            <a:ext cx="3163824" cy="457200"/>
+          <p:cNvPr id="27" name="Text 25"/>
+          <p:cNvSpPr/>
+          <p:nvPr/>
+        </p:nvSpPr>
+        <p:spPr>
+          <a:xfrm>
+            <a:off x="777240" y="5623560"/>
+            <a:ext cx="10698480" cy="566928"/>
           </a:xfrm>
           <a:prstGeom prst="rect">
             <a:avLst/>
@@ -6784,53 +7129,14 @@
           <a:ln/>
         </p:spPr>
         <p:txBody>
-          <a:bodyPr wrap="square" lIns="0" tIns="0" rIns="0" bIns="0" rtlCol="0" anchor="t"/>
-          <a:lstStyle/>
-          <a:p>
-            <a:pPr indent="0" marL="0">
-              <a:buNone/>
-            </a:pPr>
-            <a:r>
-              <a:rPr lang="en-US" sz="1500" b="1" dirty="0">
-                <a:solidFill>
-                  <a:srgbClr val="2F343A"/>
-                </a:solidFill>
-                <a:latin typeface="Arial" pitchFamily="34" charset="0"/>
-                <a:ea typeface="Arial" pitchFamily="34" charset="-122"/>
-                <a:cs typeface="Arial" pitchFamily="34" charset="-120"/>
-              </a:rPr>
-              <a:t>Fight</a:t>
-            </a:r>
-            <a:endParaRPr lang="en-US" sz="1500" dirty="0"/>
-          </a:p>
-        </p:txBody>
-      </p:sp>
-      <p:sp>
-        <p:nvSpPr>
-          <p:cNvPr id="20" name="Text 18"/>
-          <p:cNvSpPr/>
-          <p:nvPr/>
-        </p:nvSpPr>
-        <p:spPr>
-          <a:xfrm>
-            <a:off x="749808" y="3977640"/>
-            <a:ext cx="3163824" cy="1389888"/>
-          </a:xfrm>
-          <a:prstGeom prst="rect">
-            <a:avLst/>
-          </a:prstGeom>
-          <a:noFill/>
-          <a:ln/>
-        </p:spPr>
-        <p:txBody>
-          <a:bodyPr wrap="square" lIns="0" tIns="0" rIns="0" bIns="0" rtlCol="0" anchor="t"/>
-          <a:lstStyle/>
-          <a:p>
-            <a:pPr indent="0" marL="0">
-              <a:buNone/>
-            </a:pPr>
-            <a:r>
-              <a:rPr lang="en-US" sz="1150" dirty="0">
+          <a:bodyPr wrap="square" lIns="0" tIns="0" rIns="0" bIns="0" rtlCol="0" anchor="ctr"/>
+          <a:lstStyle/>
+          <a:p>
+            <a:pPr indent="0" marL="0">
+              <a:buNone/>
+            </a:pPr>
+            <a:r>
+              <a:rPr lang="en-US" sz="1300" dirty="0">
                 <a:solidFill>
                   <a:srgbClr val="2C2F33"/>
                 </a:solidFill>
@@ -6838,352 +7144,7 @@
                 <a:ea typeface="Arial" pitchFamily="34" charset="-122"/>
                 <a:cs typeface="Arial" pitchFamily="34" charset="-120"/>
               </a:rPr>
-              <a:t>Comparison and alternatives pages (your highest-value traffic). The corporate card decision guide. The core expense management guides, on depth and freshness.</a:t>
-            </a:r>
-            <a:endParaRPr lang="en-US" sz="1150" dirty="0"/>
-          </a:p>
-        </p:txBody>
-      </p:sp>
-      <p:sp>
-        <p:nvSpPr>
-          <p:cNvPr id="21" name="Shape 19"/>
-          <p:cNvSpPr/>
-          <p:nvPr/>
-        </p:nvSpPr>
-        <p:spPr>
-          <a:xfrm>
-            <a:off x="4297680" y="3200400"/>
-            <a:ext cx="3566160" cy="2286000"/>
-          </a:xfrm>
-          <a:prstGeom prst="rect">
-            <a:avLst/>
-          </a:prstGeom>
-          <a:solidFill>
-            <a:srgbClr val="F8F8F8"/>
-          </a:solidFill>
-          <a:ln w="12700">
-            <a:solidFill>
-              <a:srgbClr val="E9EFF4"/>
-            </a:solidFill>
-            <a:prstDash val="solid"/>
-          </a:ln>
-        </p:spPr>
-      </p:sp>
-      <p:sp>
-        <p:nvSpPr>
-          <p:cNvPr id="22" name="Shape 20"/>
-          <p:cNvSpPr/>
-          <p:nvPr/>
-        </p:nvSpPr>
-        <p:spPr>
-          <a:xfrm>
-            <a:off x="4297680" y="3200400"/>
-            <a:ext cx="3566160" cy="73152"/>
-          </a:xfrm>
-          <a:prstGeom prst="rect">
-            <a:avLst/>
-          </a:prstGeom>
-          <a:solidFill>
-            <a:srgbClr val="EFB438"/>
-          </a:solidFill>
-          <a:ln w="12700">
-            <a:solidFill>
-              <a:srgbClr val="EFB438"/>
-            </a:solidFill>
-            <a:prstDash val="solid"/>
-          </a:ln>
-        </p:spPr>
-      </p:sp>
-      <p:sp>
-        <p:nvSpPr>
-          <p:cNvPr id="23" name="Text 21"/>
-          <p:cNvSpPr/>
-          <p:nvPr/>
-        </p:nvSpPr>
-        <p:spPr>
-          <a:xfrm>
-            <a:off x="4498848" y="3383280"/>
-            <a:ext cx="3163824" cy="457200"/>
-          </a:xfrm>
-          <a:prstGeom prst="rect">
-            <a:avLst/>
-          </a:prstGeom>
-          <a:noFill/>
-          <a:ln/>
-        </p:spPr>
-        <p:txBody>
-          <a:bodyPr wrap="square" lIns="0" tIns="0" rIns="0" bIns="0" rtlCol="0" anchor="t"/>
-          <a:lstStyle/>
-          <a:p>
-            <a:pPr indent="0" marL="0">
-              <a:buNone/>
-            </a:pPr>
-            <a:r>
-              <a:rPr lang="en-US" sz="1500" b="1" dirty="0">
-                <a:solidFill>
-                  <a:srgbClr val="2F343A"/>
-                </a:solidFill>
-                <a:latin typeface="Arial" pitchFamily="34" charset="0"/>
-                <a:ea typeface="Arial" pitchFamily="34" charset="-122"/>
-                <a:cs typeface="Arial" pitchFamily="34" charset="-120"/>
-              </a:rPr>
-              <a:t>Flank</a:t>
-            </a:r>
-            <a:endParaRPr lang="en-US" sz="1500" dirty="0"/>
-          </a:p>
-        </p:txBody>
-      </p:sp>
-      <p:sp>
-        <p:nvSpPr>
-          <p:cNvPr id="24" name="Text 22"/>
-          <p:cNvSpPr/>
-          <p:nvPr/>
-        </p:nvSpPr>
-        <p:spPr>
-          <a:xfrm>
-            <a:off x="4498848" y="3977640"/>
-            <a:ext cx="3163824" cy="1389888"/>
-          </a:xfrm>
-          <a:prstGeom prst="rect">
-            <a:avLst/>
-          </a:prstGeom>
-          <a:noFill/>
-          <a:ln/>
-        </p:spPr>
-        <p:txBody>
-          <a:bodyPr wrap="square" lIns="0" tIns="0" rIns="0" bIns="0" rtlCol="0" anchor="t"/>
-          <a:lstStyle/>
-          <a:p>
-            <a:pPr indent="0" marL="0">
-              <a:buNone/>
-            </a:pPr>
-            <a:r>
-              <a:rPr lang="en-US" sz="1150" dirty="0">
-                <a:solidFill>
-                  <a:srgbClr val="2C2F33"/>
-                </a:solidFill>
-                <a:latin typeface="Arial" pitchFamily="34" charset="0"/>
-                <a:ea typeface="Arial" pitchFamily="34" charset="-122"/>
-                <a:cs typeface="Arial" pitchFamily="34" charset="-120"/>
-              </a:rPr>
-              <a:t>Templates and tools: policy templates, category sheets, a mileage calculator. Original data from your spend data. The spend management topic, where you are already growing.</a:t>
-            </a:r>
-            <a:endParaRPr lang="en-US" sz="1150" dirty="0"/>
-          </a:p>
-        </p:txBody>
-      </p:sp>
-      <p:sp>
-        <p:nvSpPr>
-          <p:cNvPr id="25" name="Shape 23"/>
-          <p:cNvSpPr/>
-          <p:nvPr/>
-        </p:nvSpPr>
-        <p:spPr>
-          <a:xfrm>
-            <a:off x="8046720" y="3200400"/>
-            <a:ext cx="3566160" cy="2286000"/>
-          </a:xfrm>
-          <a:prstGeom prst="rect">
-            <a:avLst/>
-          </a:prstGeom>
-          <a:solidFill>
-            <a:srgbClr val="F8F8F8"/>
-          </a:solidFill>
-          <a:ln w="12700">
-            <a:solidFill>
-              <a:srgbClr val="E9EFF4"/>
-            </a:solidFill>
-            <a:prstDash val="solid"/>
-          </a:ln>
-        </p:spPr>
-      </p:sp>
-      <p:sp>
-        <p:nvSpPr>
-          <p:cNvPr id="26" name="Shape 24"/>
-          <p:cNvSpPr/>
-          <p:nvPr/>
-        </p:nvSpPr>
-        <p:spPr>
-          <a:xfrm>
-            <a:off x="8046720" y="3200400"/>
-            <a:ext cx="3566160" cy="73152"/>
-          </a:xfrm>
-          <a:prstGeom prst="rect">
-            <a:avLst/>
-          </a:prstGeom>
-          <a:solidFill>
-            <a:srgbClr val="929194"/>
-          </a:solidFill>
-          <a:ln w="12700">
-            <a:solidFill>
-              <a:srgbClr val="929194"/>
-            </a:solidFill>
-            <a:prstDash val="solid"/>
-          </a:ln>
-        </p:spPr>
-      </p:sp>
-      <p:sp>
-        <p:nvSpPr>
-          <p:cNvPr id="27" name="Text 25"/>
-          <p:cNvSpPr/>
-          <p:nvPr/>
-        </p:nvSpPr>
-        <p:spPr>
-          <a:xfrm>
-            <a:off x="8247888" y="3383280"/>
-            <a:ext cx="3163824" cy="457200"/>
-          </a:xfrm>
-          <a:prstGeom prst="rect">
-            <a:avLst/>
-          </a:prstGeom>
-          <a:noFill/>
-          <a:ln/>
-        </p:spPr>
-        <p:txBody>
-          <a:bodyPr wrap="square" lIns="0" tIns="0" rIns="0" bIns="0" rtlCol="0" anchor="t"/>
-          <a:lstStyle/>
-          <a:p>
-            <a:pPr indent="0" marL="0">
-              <a:buNone/>
-            </a:pPr>
-            <a:r>
-              <a:rPr lang="en-US" sz="1500" b="1" dirty="0">
-                <a:solidFill>
-                  <a:srgbClr val="2F343A"/>
-                </a:solidFill>
-                <a:latin typeface="Arial" pitchFamily="34" charset="0"/>
-                <a:ea typeface="Arial" pitchFamily="34" charset="-122"/>
-                <a:cs typeface="Arial" pitchFamily="34" charset="-120"/>
-              </a:rPr>
-              <a:t>Concede</a:t>
-            </a:r>
-            <a:endParaRPr lang="en-US" sz="1500" dirty="0"/>
-          </a:p>
-        </p:txBody>
-      </p:sp>
-      <p:sp>
-        <p:nvSpPr>
-          <p:cNvPr id="28" name="Text 26"/>
-          <p:cNvSpPr/>
-          <p:nvPr/>
-        </p:nvSpPr>
-        <p:spPr>
-          <a:xfrm>
-            <a:off x="8247888" y="3977640"/>
-            <a:ext cx="3163824" cy="1389888"/>
-          </a:xfrm>
-          <a:prstGeom prst="rect">
-            <a:avLst/>
-          </a:prstGeom>
-          <a:noFill/>
-          <a:ln/>
-        </p:spPr>
-        <p:txBody>
-          <a:bodyPr wrap="square" lIns="0" tIns="0" rIns="0" bIns="0" rtlCol="0" anchor="t"/>
-          <a:lstStyle/>
-          <a:p>
-            <a:pPr indent="0" marL="0">
-              <a:buNone/>
-            </a:pPr>
-            <a:r>
-              <a:rPr lang="en-US" sz="1150" dirty="0">
-                <a:solidFill>
-                  <a:srgbClr val="2C2F33"/>
-                </a:solidFill>
-                <a:latin typeface="Arial" pitchFamily="34" charset="0"/>
-                <a:ea typeface="Arial" pitchFamily="34" charset="-122"/>
-                <a:cs typeface="Arial" pitchFamily="34" charset="-120"/>
-              </a:rPr>
-              <a:t>Generic finance education (invoicing, bookkeeping, accounting software lists). Per diem and tax deadline rate pages that government sites own. Consumer searches like receipt scanning apps.</a:t>
-            </a:r>
-            <a:endParaRPr lang="en-US" sz="1150" dirty="0"/>
-          </a:p>
-        </p:txBody>
-      </p:sp>
-      <p:sp>
-        <p:nvSpPr>
-          <p:cNvPr id="29" name="Shape 27"/>
-          <p:cNvSpPr/>
-          <p:nvPr/>
-        </p:nvSpPr>
-        <p:spPr>
-          <a:xfrm>
-            <a:off x="548640" y="5623560"/>
-            <a:ext cx="11064240" cy="566928"/>
-          </a:xfrm>
-          <a:prstGeom prst="rect">
-            <a:avLst/>
-          </a:prstGeom>
-          <a:solidFill>
-            <a:srgbClr val="E9EFF4"/>
-          </a:solidFill>
-          <a:ln w="12700">
-            <a:solidFill>
-              <a:srgbClr val="E9EFF4"/>
-            </a:solidFill>
-            <a:prstDash val="solid"/>
-          </a:ln>
-        </p:spPr>
-      </p:sp>
-      <p:sp>
-        <p:nvSpPr>
-          <p:cNvPr id="30" name="Shape 28"/>
-          <p:cNvSpPr/>
-          <p:nvPr/>
-        </p:nvSpPr>
-        <p:spPr>
-          <a:xfrm>
-            <a:off x="548640" y="5623560"/>
-            <a:ext cx="82296" cy="566928"/>
-          </a:xfrm>
-          <a:prstGeom prst="rect">
-            <a:avLst/>
-          </a:prstGeom>
-          <a:solidFill>
-            <a:srgbClr val="F27038"/>
-          </a:solidFill>
-          <a:ln w="12700">
-            <a:solidFill>
-              <a:srgbClr val="F27038"/>
-            </a:solidFill>
-            <a:prstDash val="solid"/>
-          </a:ln>
-        </p:spPr>
-      </p:sp>
-      <p:sp>
-        <p:nvSpPr>
-          <p:cNvPr id="31" name="Text 29"/>
-          <p:cNvSpPr/>
-          <p:nvPr/>
-        </p:nvSpPr>
-        <p:spPr>
-          <a:xfrm>
-            <a:off x="777240" y="5623560"/>
-            <a:ext cx="10698480" cy="566928"/>
-          </a:xfrm>
-          <a:prstGeom prst="rect">
-            <a:avLst/>
-          </a:prstGeom>
-          <a:noFill/>
-          <a:ln/>
-        </p:spPr>
-        <p:txBody>
-          <a:bodyPr wrap="square" lIns="0" tIns="0" rIns="0" bIns="0" rtlCol="0" anchor="ctr"/>
-          <a:lstStyle/>
-          <a:p>
-            <a:pPr indent="0" marL="0">
-              <a:buNone/>
-            </a:pPr>
-            <a:r>
-              <a:rPr lang="en-US" sz="1300" dirty="0">
-                <a:solidFill>
-                  <a:srgbClr val="2C2F33"/>
-                </a:solidFill>
-                <a:latin typeface="Arial" pitchFamily="34" charset="0"/>
-                <a:ea typeface="Arial" pitchFamily="34" charset="-122"/>
-                <a:cs typeface="Arial" pitchFamily="34" charset="-120"/>
-              </a:rPr>
-              <a:t>Ramp is a volume publisher. Volume is the one game we cannot win on this budget, so we do not enter it.</a:t>
+              <a:t>Nothing publishes without a person signing it off. The saving is real only if the edited pages perform as well as the written ones, so we test before we switch.</a:t>
             </a:r>
             <a:endParaRPr lang="en-US" sz="1300" dirty="0"/>
           </a:p>
@@ -7279,7 +7240,7 @@
                 <a:ea typeface="Arial" pitchFamily="34" charset="-122"/>
                 <a:cs typeface="Arial" pitchFamily="34" charset="-120"/>
               </a:rPr>
-              <a:t>WHAT TO EXPECT</a:t>
+              <a:t>THE COMPETITION</a:t>
             </a:r>
             <a:endParaRPr lang="en-US" sz="1100" dirty="0"/>
           </a:p>
@@ -7318,7 +7279,7 @@
                 <a:ea typeface="Arial" pitchFamily="34" charset="-122"/>
                 <a:cs typeface="Arial" pitchFamily="34" charset="-120"/>
               </a:rPr>
-              <a:t>By month 12: leads roughly double in the base case, and traffic lands between about 100K and 135K. 140K sits above our stretch case.</a:t>
+              <a:t>We will not out-publish Ramp. We win where they do not play.</a:t>
             </a:r>
             <a:endParaRPr lang="en-US" sz="2600" dirty="0"/>
           </a:p>
@@ -7449,54 +7410,47 @@
                 <a:ea typeface="Arial" pitchFamily="34" charset="-122"/>
                 <a:cs typeface="Arial" pitchFamily="34" charset="-120"/>
               </a:rPr>
-              <a:t>Three scenarios, not a forecast. The base case assumes the top-page sample's mix holds for the whole site; week-one Search Console data replaces that assumption.</a:t>
+              <a:t>Source: Ramp's publishing pace from your brief; linking sites gained per month from a public backlink index, 12 months to September 2026</a:t>
             </a:r>
             <a:endParaRPr lang="en-US" sz="850" dirty="0"/>
           </a:p>
         </p:txBody>
       </p:sp>
-      <p:graphicFrame>
-        <p:nvGraphicFramePr>
-          <p:cNvPr id="8" name="Chart 0" descr=""/>
-          <p:cNvGraphicFramePr/>
-          <p:nvPr/>
-        </p:nvGraphicFramePr>
-        <p:xfrm>
-          <a:off x="548640" y="1828800"/>
-          <a:ext cx="5486400" cy="3200400"/>
-        </p:xfrm>
-        <a:graphic xmlns:a="http://schemas.openxmlformats.org/drawingml/2006/main">
-          <a:graphicData uri="http://schemas.openxmlformats.org/drawingml/2006/chart">
-            <c:chart xmlns:c="http://schemas.openxmlformats.org/drawingml/2006/chart" r:id="rId1"/>
-          </a:graphicData>
-        </a:graphic>
-      </p:graphicFrame>
-      <p:graphicFrame>
-        <p:nvGraphicFramePr>
-          <p:cNvPr id="9" name="Chart 1" descr=""/>
-          <p:cNvGraphicFramePr/>
-          <p:nvPr/>
-        </p:nvGraphicFramePr>
-        <p:xfrm>
-          <a:off x="6217920" y="1828800"/>
-          <a:ext cx="5394960" cy="3200400"/>
-        </p:xfrm>
-        <a:graphic xmlns:a="http://schemas.openxmlformats.org/drawingml/2006/main">
-          <a:graphicData uri="http://schemas.openxmlformats.org/drawingml/2006/chart">
-            <c:chart xmlns:c="http://schemas.openxmlformats.org/drawingml/2006/chart" r:id="rId2"/>
-          </a:graphicData>
-        </a:graphic>
-      </p:graphicFrame>
-      <p:sp>
-        <p:nvSpPr>
-          <p:cNvPr id="10" name="Text 6"/>
-          <p:cNvSpPr/>
-          <p:nvPr/>
-        </p:nvSpPr>
-        <p:spPr>
-          <a:xfrm>
-            <a:off x="548640" y="5074920"/>
-            <a:ext cx="11064240" cy="548640"/>
+      <p:sp>
+        <p:nvSpPr>
+          <p:cNvPr id="8" name="Shape 6"/>
+          <p:cNvSpPr/>
+          <p:nvPr/>
+        </p:nvSpPr>
+        <p:spPr>
+          <a:xfrm>
+            <a:off x="548640" y="1828800"/>
+            <a:ext cx="3566160" cy="1188720"/>
+          </a:xfrm>
+          <a:prstGeom prst="rect">
+            <a:avLst/>
+          </a:prstGeom>
+          <a:solidFill>
+            <a:srgbClr val="F8F8F8"/>
+          </a:solidFill>
+          <a:ln w="12700">
+            <a:solidFill>
+              <a:srgbClr val="E9EFF4"/>
+            </a:solidFill>
+            <a:prstDash val="solid"/>
+          </a:ln>
+        </p:spPr>
+      </p:sp>
+      <p:sp>
+        <p:nvSpPr>
+          <p:cNvPr id="9" name="Text 7"/>
+          <p:cNvSpPr/>
+          <p:nvPr/>
+        </p:nvSpPr>
+        <p:spPr>
+          <a:xfrm>
+            <a:off x="731520" y="1938528"/>
+            <a:ext cx="3200400" cy="594360"/>
           </a:xfrm>
           <a:prstGeom prst="rect">
             <a:avLst/>
@@ -7505,6 +7459,45 @@
           <a:ln/>
         </p:spPr>
         <p:txBody>
+          <a:bodyPr wrap="square" lIns="0" tIns="0" rIns="0" bIns="0" rtlCol="0" anchor="ctr"/>
+          <a:lstStyle/>
+          <a:p>
+            <a:pPr indent="0" marL="0">
+              <a:buNone/>
+            </a:pPr>
+            <a:r>
+              <a:rPr lang="en-US" sz="3000" b="1" dirty="0">
+                <a:solidFill>
+                  <a:srgbClr val="F27038"/>
+                </a:solidFill>
+                <a:latin typeface="Arial" pitchFamily="34" charset="0"/>
+                <a:ea typeface="Arial" pitchFamily="34" charset="-122"/>
+                <a:cs typeface="Arial" pitchFamily="34" charset="-120"/>
+              </a:rPr>
+              <a:t>100 vs 48</a:t>
+            </a:r>
+            <a:endParaRPr lang="en-US" sz="3000" dirty="0"/>
+          </a:p>
+        </p:txBody>
+      </p:sp>
+      <p:sp>
+        <p:nvSpPr>
+          <p:cNvPr id="10" name="Text 8"/>
+          <p:cNvSpPr/>
+          <p:nvPr/>
+        </p:nvSpPr>
+        <p:spPr>
+          <a:xfrm>
+            <a:off x="731520" y="2482596"/>
+            <a:ext cx="3200400" cy="475488"/>
+          </a:xfrm>
+          <a:prstGeom prst="rect">
+            <a:avLst/>
+          </a:prstGeom>
+          <a:noFill/>
+          <a:ln/>
+        </p:spPr>
+        <p:txBody>
           <a:bodyPr wrap="square" lIns="0" tIns="0" rIns="0" bIns="0" rtlCol="0" anchor="t"/>
           <a:lstStyle/>
           <a:p>
@@ -7512,30 +7505,620 @@
               <a:buNone/>
             </a:pPr>
             <a:r>
-              <a:rPr lang="en-US" sz="1100" dirty="0">
-                <a:solidFill>
-                  <a:srgbClr val="6C757D"/>
-                </a:solidFill>
-                <a:latin typeface="Arial" pitchFamily="34" charset="0"/>
-                <a:ea typeface="Arial" pitchFamily="34" charset="-122"/>
-                <a:cs typeface="Arial" pitchFamily="34" charset="-120"/>
-              </a:rPr>
-              <a:t>Month 12, base case: about 117,000 visits and 2.2x leads. Low: 101,000 and 1.5x. Stretch: 136,000 and 3x. Why even the stretch case stays under 140K: your biggest searches now have an AI answer on top, and the two expired pages were queries that government sites now own. Growth beyond the base case comes from new comparison pages and templates, not from the old pages returning to their old numbers.</a:t>
-            </a:r>
-            <a:endParaRPr lang="en-US" sz="1100" dirty="0"/>
-          </a:p>
-        </p:txBody>
-      </p:sp>
-      <p:sp>
-        <p:nvSpPr>
-          <p:cNvPr id="11" name="Shape 7"/>
-          <p:cNvSpPr/>
-          <p:nvPr/>
-        </p:nvSpPr>
-        <p:spPr>
-          <a:xfrm>
-            <a:off x="548640" y="5715000"/>
-            <a:ext cx="11064240" cy="502920"/>
+              <a:rPr lang="en-US" sz="1150" dirty="0">
+                <a:solidFill>
+                  <a:srgbClr val="2C2F33"/>
+                </a:solidFill>
+                <a:latin typeface="Arial" pitchFamily="34" charset="0"/>
+                <a:ea typeface="Arial" pitchFamily="34" charset="-122"/>
+                <a:cs typeface="Arial" pitchFamily="34" charset="-120"/>
+              </a:rPr>
+              <a:t>posts a year: Ramp's pace against yours</a:t>
+            </a:r>
+            <a:endParaRPr lang="en-US" sz="1150" dirty="0"/>
+          </a:p>
+        </p:txBody>
+      </p:sp>
+      <p:sp>
+        <p:nvSpPr>
+          <p:cNvPr id="11" name="Shape 9"/>
+          <p:cNvSpPr/>
+          <p:nvPr/>
+        </p:nvSpPr>
+        <p:spPr>
+          <a:xfrm>
+            <a:off x="4297680" y="1828800"/>
+            <a:ext cx="3566160" cy="1188720"/>
+          </a:xfrm>
+          <a:prstGeom prst="rect">
+            <a:avLst/>
+          </a:prstGeom>
+          <a:solidFill>
+            <a:srgbClr val="F8F8F8"/>
+          </a:solidFill>
+          <a:ln w="12700">
+            <a:solidFill>
+              <a:srgbClr val="E9EFF4"/>
+            </a:solidFill>
+            <a:prstDash val="solid"/>
+          </a:ln>
+        </p:spPr>
+      </p:sp>
+      <p:sp>
+        <p:nvSpPr>
+          <p:cNvPr id="12" name="Text 10"/>
+          <p:cNvSpPr/>
+          <p:nvPr/>
+        </p:nvSpPr>
+        <p:spPr>
+          <a:xfrm>
+            <a:off x="4480560" y="1938528"/>
+            <a:ext cx="3200400" cy="594360"/>
+          </a:xfrm>
+          <a:prstGeom prst="rect">
+            <a:avLst/>
+          </a:prstGeom>
+          <a:noFill/>
+          <a:ln/>
+        </p:spPr>
+        <p:txBody>
+          <a:bodyPr wrap="square" lIns="0" tIns="0" rIns="0" bIns="0" rtlCol="0" anchor="ctr"/>
+          <a:lstStyle/>
+          <a:p>
+            <a:pPr indent="0" marL="0">
+              <a:buNone/>
+            </a:pPr>
+            <a:r>
+              <a:rPr lang="en-US" sz="3000" b="1" dirty="0">
+                <a:solidFill>
+                  <a:srgbClr val="F27038"/>
+                </a:solidFill>
+                <a:latin typeface="Arial" pitchFamily="34" charset="0"/>
+                <a:ea typeface="Arial" pitchFamily="34" charset="-122"/>
+                <a:cs typeface="Arial" pitchFamily="34" charset="-120"/>
+              </a:rPr>
+              <a:t>340</a:t>
+            </a:r>
+            <a:endParaRPr lang="en-US" sz="3000" dirty="0"/>
+          </a:p>
+        </p:txBody>
+      </p:sp>
+      <p:sp>
+        <p:nvSpPr>
+          <p:cNvPr id="13" name="Text 11"/>
+          <p:cNvSpPr/>
+          <p:nvPr/>
+        </p:nvSpPr>
+        <p:spPr>
+          <a:xfrm>
+            <a:off x="4480560" y="2482596"/>
+            <a:ext cx="3200400" cy="475488"/>
+          </a:xfrm>
+          <a:prstGeom prst="rect">
+            <a:avLst/>
+          </a:prstGeom>
+          <a:noFill/>
+          <a:ln/>
+        </p:spPr>
+        <p:txBody>
+          <a:bodyPr wrap="square" lIns="0" tIns="0" rIns="0" bIns="0" rtlCol="0" anchor="t"/>
+          <a:lstStyle/>
+          <a:p>
+            <a:pPr indent="0" marL="0">
+              <a:buNone/>
+            </a:pPr>
+            <a:r>
+              <a:rPr lang="en-US" sz="1150" dirty="0">
+                <a:solidFill>
+                  <a:srgbClr val="2C2F33"/>
+                </a:solidFill>
+                <a:latin typeface="Arial" pitchFamily="34" charset="0"/>
+                <a:ea typeface="Arial" pitchFamily="34" charset="-122"/>
+                <a:cs typeface="Arial" pitchFamily="34" charset="-120"/>
+              </a:rPr>
+              <a:t>new websites linking to Ramp every month</a:t>
+            </a:r>
+            <a:endParaRPr lang="en-US" sz="1150" dirty="0"/>
+          </a:p>
+        </p:txBody>
+      </p:sp>
+      <p:sp>
+        <p:nvSpPr>
+          <p:cNvPr id="14" name="Shape 12"/>
+          <p:cNvSpPr/>
+          <p:nvPr/>
+        </p:nvSpPr>
+        <p:spPr>
+          <a:xfrm>
+            <a:off x="8046720" y="1828800"/>
+            <a:ext cx="3566160" cy="1188720"/>
+          </a:xfrm>
+          <a:prstGeom prst="rect">
+            <a:avLst/>
+          </a:prstGeom>
+          <a:solidFill>
+            <a:srgbClr val="2F343A"/>
+          </a:solidFill>
+          <a:ln w="12700">
+            <a:solidFill>
+              <a:srgbClr val="2F343A"/>
+            </a:solidFill>
+            <a:prstDash val="solid"/>
+          </a:ln>
+        </p:spPr>
+      </p:sp>
+      <p:sp>
+        <p:nvSpPr>
+          <p:cNvPr id="15" name="Text 13"/>
+          <p:cNvSpPr/>
+          <p:nvPr/>
+        </p:nvSpPr>
+        <p:spPr>
+          <a:xfrm>
+            <a:off x="8229600" y="1938528"/>
+            <a:ext cx="3200400" cy="594360"/>
+          </a:xfrm>
+          <a:prstGeom prst="rect">
+            <a:avLst/>
+          </a:prstGeom>
+          <a:noFill/>
+          <a:ln/>
+        </p:spPr>
+        <p:txBody>
+          <a:bodyPr wrap="square" lIns="0" tIns="0" rIns="0" bIns="0" rtlCol="0" anchor="ctr"/>
+          <a:lstStyle/>
+          <a:p>
+            <a:pPr indent="0" marL="0">
+              <a:buNone/>
+            </a:pPr>
+            <a:r>
+              <a:rPr lang="en-US" sz="3000" b="1" dirty="0">
+                <a:solidFill>
+                  <a:srgbClr val="FFFFFF"/>
+                </a:solidFill>
+                <a:latin typeface="Arial" pitchFamily="34" charset="0"/>
+                <a:ea typeface="Arial" pitchFamily="34" charset="-122"/>
+                <a:cs typeface="Arial" pitchFamily="34" charset="-120"/>
+              </a:rPr>
+              <a:t>5x</a:t>
+            </a:r>
+            <a:endParaRPr lang="en-US" sz="3000" dirty="0"/>
+          </a:p>
+        </p:txBody>
+      </p:sp>
+      <p:sp>
+        <p:nvSpPr>
+          <p:cNvPr id="16" name="Text 14"/>
+          <p:cNvSpPr/>
+          <p:nvPr/>
+        </p:nvSpPr>
+        <p:spPr>
+          <a:xfrm>
+            <a:off x="8229600" y="2482596"/>
+            <a:ext cx="3200400" cy="475488"/>
+          </a:xfrm>
+          <a:prstGeom prst="rect">
+            <a:avLst/>
+          </a:prstGeom>
+          <a:noFill/>
+          <a:ln/>
+        </p:spPr>
+        <p:txBody>
+          <a:bodyPr wrap="square" lIns="0" tIns="0" rIns="0" bIns="0" rtlCol="0" anchor="t"/>
+          <a:lstStyle/>
+          <a:p>
+            <a:pPr indent="0" marL="0">
+              <a:buNone/>
+            </a:pPr>
+            <a:r>
+              <a:rPr lang="en-US" sz="1150" dirty="0">
+                <a:solidFill>
+                  <a:srgbClr val="E9EFF4"/>
+                </a:solidFill>
+                <a:latin typeface="Arial" pitchFamily="34" charset="0"/>
+                <a:ea typeface="Arial" pitchFamily="34" charset="-122"/>
+                <a:cs typeface="Arial" pitchFamily="34" charset="-120"/>
+              </a:rPr>
+              <a:t>your traffic. Ramp is a much bigger site</a:t>
+            </a:r>
+            <a:endParaRPr lang="en-US" sz="1150" dirty="0"/>
+          </a:p>
+        </p:txBody>
+      </p:sp>
+      <p:sp>
+        <p:nvSpPr>
+          <p:cNvPr id="17" name="Shape 15"/>
+          <p:cNvSpPr/>
+          <p:nvPr/>
+        </p:nvSpPr>
+        <p:spPr>
+          <a:xfrm>
+            <a:off x="548640" y="3200400"/>
+            <a:ext cx="3566160" cy="2286000"/>
+          </a:xfrm>
+          <a:prstGeom prst="rect">
+            <a:avLst/>
+          </a:prstGeom>
+          <a:solidFill>
+            <a:srgbClr val="F8F8F8"/>
+          </a:solidFill>
+          <a:ln w="12700">
+            <a:solidFill>
+              <a:srgbClr val="E9EFF4"/>
+            </a:solidFill>
+            <a:prstDash val="solid"/>
+          </a:ln>
+        </p:spPr>
+      </p:sp>
+      <p:sp>
+        <p:nvSpPr>
+          <p:cNvPr id="18" name="Shape 16"/>
+          <p:cNvSpPr/>
+          <p:nvPr/>
+        </p:nvSpPr>
+        <p:spPr>
+          <a:xfrm>
+            <a:off x="548640" y="3200400"/>
+            <a:ext cx="3566160" cy="73152"/>
+          </a:xfrm>
+          <a:prstGeom prst="rect">
+            <a:avLst/>
+          </a:prstGeom>
+          <a:solidFill>
+            <a:srgbClr val="F27038"/>
+          </a:solidFill>
+          <a:ln w="12700">
+            <a:solidFill>
+              <a:srgbClr val="F27038"/>
+            </a:solidFill>
+            <a:prstDash val="solid"/>
+          </a:ln>
+        </p:spPr>
+      </p:sp>
+      <p:sp>
+        <p:nvSpPr>
+          <p:cNvPr id="19" name="Text 17"/>
+          <p:cNvSpPr/>
+          <p:nvPr/>
+        </p:nvSpPr>
+        <p:spPr>
+          <a:xfrm>
+            <a:off x="749808" y="3383280"/>
+            <a:ext cx="3163824" cy="457200"/>
+          </a:xfrm>
+          <a:prstGeom prst="rect">
+            <a:avLst/>
+          </a:prstGeom>
+          <a:noFill/>
+          <a:ln/>
+        </p:spPr>
+        <p:txBody>
+          <a:bodyPr wrap="square" lIns="0" tIns="0" rIns="0" bIns="0" rtlCol="0" anchor="t"/>
+          <a:lstStyle/>
+          <a:p>
+            <a:pPr indent="0" marL="0">
+              <a:buNone/>
+            </a:pPr>
+            <a:r>
+              <a:rPr lang="en-US" sz="1500" b="1" dirty="0">
+                <a:solidFill>
+                  <a:srgbClr val="2F343A"/>
+                </a:solidFill>
+                <a:latin typeface="Arial" pitchFamily="34" charset="0"/>
+                <a:ea typeface="Arial" pitchFamily="34" charset="-122"/>
+                <a:cs typeface="Arial" pitchFamily="34" charset="-120"/>
+              </a:rPr>
+              <a:t>Fight</a:t>
+            </a:r>
+            <a:endParaRPr lang="en-US" sz="1500" dirty="0"/>
+          </a:p>
+        </p:txBody>
+      </p:sp>
+      <p:sp>
+        <p:nvSpPr>
+          <p:cNvPr id="20" name="Text 18"/>
+          <p:cNvSpPr/>
+          <p:nvPr/>
+        </p:nvSpPr>
+        <p:spPr>
+          <a:xfrm>
+            <a:off x="749808" y="3977640"/>
+            <a:ext cx="3163824" cy="1389888"/>
+          </a:xfrm>
+          <a:prstGeom prst="rect">
+            <a:avLst/>
+          </a:prstGeom>
+          <a:noFill/>
+          <a:ln/>
+        </p:spPr>
+        <p:txBody>
+          <a:bodyPr wrap="square" lIns="0" tIns="0" rIns="0" bIns="0" rtlCol="0" anchor="t"/>
+          <a:lstStyle/>
+          <a:p>
+            <a:pPr indent="0" marL="0">
+              <a:buNone/>
+            </a:pPr>
+            <a:r>
+              <a:rPr lang="en-US" sz="1150" dirty="0">
+                <a:solidFill>
+                  <a:srgbClr val="2C2F33"/>
+                </a:solidFill>
+                <a:latin typeface="Arial" pitchFamily="34" charset="0"/>
+                <a:ea typeface="Arial" pitchFamily="34" charset="-122"/>
+                <a:cs typeface="Arial" pitchFamily="34" charset="-120"/>
+              </a:rPr>
+              <a:t>Comparison and alternatives pages (your highest-value traffic). The corporate card decision guide. The core expense management guides, on depth and freshness.</a:t>
+            </a:r>
+            <a:endParaRPr lang="en-US" sz="1150" dirty="0"/>
+          </a:p>
+        </p:txBody>
+      </p:sp>
+      <p:sp>
+        <p:nvSpPr>
+          <p:cNvPr id="21" name="Shape 19"/>
+          <p:cNvSpPr/>
+          <p:nvPr/>
+        </p:nvSpPr>
+        <p:spPr>
+          <a:xfrm>
+            <a:off x="4297680" y="3200400"/>
+            <a:ext cx="3566160" cy="2286000"/>
+          </a:xfrm>
+          <a:prstGeom prst="rect">
+            <a:avLst/>
+          </a:prstGeom>
+          <a:solidFill>
+            <a:srgbClr val="F8F8F8"/>
+          </a:solidFill>
+          <a:ln w="12700">
+            <a:solidFill>
+              <a:srgbClr val="E9EFF4"/>
+            </a:solidFill>
+            <a:prstDash val="solid"/>
+          </a:ln>
+        </p:spPr>
+      </p:sp>
+      <p:sp>
+        <p:nvSpPr>
+          <p:cNvPr id="22" name="Shape 20"/>
+          <p:cNvSpPr/>
+          <p:nvPr/>
+        </p:nvSpPr>
+        <p:spPr>
+          <a:xfrm>
+            <a:off x="4297680" y="3200400"/>
+            <a:ext cx="3566160" cy="73152"/>
+          </a:xfrm>
+          <a:prstGeom prst="rect">
+            <a:avLst/>
+          </a:prstGeom>
+          <a:solidFill>
+            <a:srgbClr val="EFB438"/>
+          </a:solidFill>
+          <a:ln w="12700">
+            <a:solidFill>
+              <a:srgbClr val="EFB438"/>
+            </a:solidFill>
+            <a:prstDash val="solid"/>
+          </a:ln>
+        </p:spPr>
+      </p:sp>
+      <p:sp>
+        <p:nvSpPr>
+          <p:cNvPr id="23" name="Text 21"/>
+          <p:cNvSpPr/>
+          <p:nvPr/>
+        </p:nvSpPr>
+        <p:spPr>
+          <a:xfrm>
+            <a:off x="4498848" y="3383280"/>
+            <a:ext cx="3163824" cy="457200"/>
+          </a:xfrm>
+          <a:prstGeom prst="rect">
+            <a:avLst/>
+          </a:prstGeom>
+          <a:noFill/>
+          <a:ln/>
+        </p:spPr>
+        <p:txBody>
+          <a:bodyPr wrap="square" lIns="0" tIns="0" rIns="0" bIns="0" rtlCol="0" anchor="t"/>
+          <a:lstStyle/>
+          <a:p>
+            <a:pPr indent="0" marL="0">
+              <a:buNone/>
+            </a:pPr>
+            <a:r>
+              <a:rPr lang="en-US" sz="1500" b="1" dirty="0">
+                <a:solidFill>
+                  <a:srgbClr val="2F343A"/>
+                </a:solidFill>
+                <a:latin typeface="Arial" pitchFamily="34" charset="0"/>
+                <a:ea typeface="Arial" pitchFamily="34" charset="-122"/>
+                <a:cs typeface="Arial" pitchFamily="34" charset="-120"/>
+              </a:rPr>
+              <a:t>Flank</a:t>
+            </a:r>
+            <a:endParaRPr lang="en-US" sz="1500" dirty="0"/>
+          </a:p>
+        </p:txBody>
+      </p:sp>
+      <p:sp>
+        <p:nvSpPr>
+          <p:cNvPr id="24" name="Text 22"/>
+          <p:cNvSpPr/>
+          <p:nvPr/>
+        </p:nvSpPr>
+        <p:spPr>
+          <a:xfrm>
+            <a:off x="4498848" y="3977640"/>
+            <a:ext cx="3163824" cy="1389888"/>
+          </a:xfrm>
+          <a:prstGeom prst="rect">
+            <a:avLst/>
+          </a:prstGeom>
+          <a:noFill/>
+          <a:ln/>
+        </p:spPr>
+        <p:txBody>
+          <a:bodyPr wrap="square" lIns="0" tIns="0" rIns="0" bIns="0" rtlCol="0" anchor="t"/>
+          <a:lstStyle/>
+          <a:p>
+            <a:pPr indent="0" marL="0">
+              <a:buNone/>
+            </a:pPr>
+            <a:r>
+              <a:rPr lang="en-US" sz="1150" dirty="0">
+                <a:solidFill>
+                  <a:srgbClr val="2C2F33"/>
+                </a:solidFill>
+                <a:latin typeface="Arial" pitchFamily="34" charset="0"/>
+                <a:ea typeface="Arial" pitchFamily="34" charset="-122"/>
+                <a:cs typeface="Arial" pitchFamily="34" charset="-120"/>
+              </a:rPr>
+              <a:t>Templates and tools: policy templates, category sheets, a mileage calculator. Original data from your spend data. The spend management topic, where you are already growing.</a:t>
+            </a:r>
+            <a:endParaRPr lang="en-US" sz="1150" dirty="0"/>
+          </a:p>
+        </p:txBody>
+      </p:sp>
+      <p:sp>
+        <p:nvSpPr>
+          <p:cNvPr id="25" name="Shape 23"/>
+          <p:cNvSpPr/>
+          <p:nvPr/>
+        </p:nvSpPr>
+        <p:spPr>
+          <a:xfrm>
+            <a:off x="8046720" y="3200400"/>
+            <a:ext cx="3566160" cy="2286000"/>
+          </a:xfrm>
+          <a:prstGeom prst="rect">
+            <a:avLst/>
+          </a:prstGeom>
+          <a:solidFill>
+            <a:srgbClr val="F8F8F8"/>
+          </a:solidFill>
+          <a:ln w="12700">
+            <a:solidFill>
+              <a:srgbClr val="E9EFF4"/>
+            </a:solidFill>
+            <a:prstDash val="solid"/>
+          </a:ln>
+        </p:spPr>
+      </p:sp>
+      <p:sp>
+        <p:nvSpPr>
+          <p:cNvPr id="26" name="Shape 24"/>
+          <p:cNvSpPr/>
+          <p:nvPr/>
+        </p:nvSpPr>
+        <p:spPr>
+          <a:xfrm>
+            <a:off x="8046720" y="3200400"/>
+            <a:ext cx="3566160" cy="73152"/>
+          </a:xfrm>
+          <a:prstGeom prst="rect">
+            <a:avLst/>
+          </a:prstGeom>
+          <a:solidFill>
+            <a:srgbClr val="929194"/>
+          </a:solidFill>
+          <a:ln w="12700">
+            <a:solidFill>
+              <a:srgbClr val="929194"/>
+            </a:solidFill>
+            <a:prstDash val="solid"/>
+          </a:ln>
+        </p:spPr>
+      </p:sp>
+      <p:sp>
+        <p:nvSpPr>
+          <p:cNvPr id="27" name="Text 25"/>
+          <p:cNvSpPr/>
+          <p:nvPr/>
+        </p:nvSpPr>
+        <p:spPr>
+          <a:xfrm>
+            <a:off x="8247888" y="3383280"/>
+            <a:ext cx="3163824" cy="457200"/>
+          </a:xfrm>
+          <a:prstGeom prst="rect">
+            <a:avLst/>
+          </a:prstGeom>
+          <a:noFill/>
+          <a:ln/>
+        </p:spPr>
+        <p:txBody>
+          <a:bodyPr wrap="square" lIns="0" tIns="0" rIns="0" bIns="0" rtlCol="0" anchor="t"/>
+          <a:lstStyle/>
+          <a:p>
+            <a:pPr indent="0" marL="0">
+              <a:buNone/>
+            </a:pPr>
+            <a:r>
+              <a:rPr lang="en-US" sz="1500" b="1" dirty="0">
+                <a:solidFill>
+                  <a:srgbClr val="2F343A"/>
+                </a:solidFill>
+                <a:latin typeface="Arial" pitchFamily="34" charset="0"/>
+                <a:ea typeface="Arial" pitchFamily="34" charset="-122"/>
+                <a:cs typeface="Arial" pitchFamily="34" charset="-120"/>
+              </a:rPr>
+              <a:t>Concede</a:t>
+            </a:r>
+            <a:endParaRPr lang="en-US" sz="1500" dirty="0"/>
+          </a:p>
+        </p:txBody>
+      </p:sp>
+      <p:sp>
+        <p:nvSpPr>
+          <p:cNvPr id="28" name="Text 26"/>
+          <p:cNvSpPr/>
+          <p:nvPr/>
+        </p:nvSpPr>
+        <p:spPr>
+          <a:xfrm>
+            <a:off x="8247888" y="3977640"/>
+            <a:ext cx="3163824" cy="1389888"/>
+          </a:xfrm>
+          <a:prstGeom prst="rect">
+            <a:avLst/>
+          </a:prstGeom>
+          <a:noFill/>
+          <a:ln/>
+        </p:spPr>
+        <p:txBody>
+          <a:bodyPr wrap="square" lIns="0" tIns="0" rIns="0" bIns="0" rtlCol="0" anchor="t"/>
+          <a:lstStyle/>
+          <a:p>
+            <a:pPr indent="0" marL="0">
+              <a:buNone/>
+            </a:pPr>
+            <a:r>
+              <a:rPr lang="en-US" sz="1150" dirty="0">
+                <a:solidFill>
+                  <a:srgbClr val="2C2F33"/>
+                </a:solidFill>
+                <a:latin typeface="Arial" pitchFamily="34" charset="0"/>
+                <a:ea typeface="Arial" pitchFamily="34" charset="-122"/>
+                <a:cs typeface="Arial" pitchFamily="34" charset="-120"/>
+              </a:rPr>
+              <a:t>Generic finance education (invoicing, bookkeeping, accounting software lists). Per diem and tax deadline rate pages that government sites own. Consumer searches like receipt scanning apps.</a:t>
+            </a:r>
+            <a:endParaRPr lang="en-US" sz="1150" dirty="0"/>
+          </a:p>
+        </p:txBody>
+      </p:sp>
+      <p:sp>
+        <p:nvSpPr>
+          <p:cNvPr id="29" name="Shape 27"/>
+          <p:cNvSpPr/>
+          <p:nvPr/>
+        </p:nvSpPr>
+        <p:spPr>
+          <a:xfrm>
+            <a:off x="548640" y="5623560"/>
+            <a:ext cx="11064240" cy="566928"/>
           </a:xfrm>
           <a:prstGeom prst="rect">
             <a:avLst/>
@@ -7553,14 +8136,14 @@
       </p:sp>
       <p:sp>
         <p:nvSpPr>
-          <p:cNvPr id="12" name="Shape 8"/>
-          <p:cNvSpPr/>
-          <p:nvPr/>
-        </p:nvSpPr>
-        <p:spPr>
-          <a:xfrm>
-            <a:off x="548640" y="5715000"/>
-            <a:ext cx="82296" cy="502920"/>
+          <p:cNvPr id="30" name="Shape 28"/>
+          <p:cNvSpPr/>
+          <p:nvPr/>
+        </p:nvSpPr>
+        <p:spPr>
+          <a:xfrm>
+            <a:off x="548640" y="5623560"/>
+            <a:ext cx="82296" cy="566928"/>
           </a:xfrm>
           <a:prstGeom prst="rect">
             <a:avLst/>
@@ -7578,14 +8161,14 @@
       </p:sp>
       <p:sp>
         <p:nvSpPr>
-          <p:cNvPr id="13" name="Text 9"/>
-          <p:cNvSpPr/>
-          <p:nvPr/>
-        </p:nvSpPr>
-        <p:spPr>
-          <a:xfrm>
-            <a:off x="777240" y="5715000"/>
-            <a:ext cx="10698480" cy="502920"/>
+          <p:cNvPr id="31" name="Text 29"/>
+          <p:cNvSpPr/>
+          <p:nvPr/>
+        </p:nvSpPr>
+        <p:spPr>
+          <a:xfrm>
+            <a:off x="777240" y="5623560"/>
+            <a:ext cx="10698480" cy="566928"/>
           </a:xfrm>
           <a:prstGeom prst="rect">
             <a:avLst/>
@@ -7609,7 +8192,7 @@
                 <a:ea typeface="Arial" pitchFamily="34" charset="-122"/>
                 <a:cs typeface="Arial" pitchFamily="34" charset="-120"/>
               </a:rPr>
-              <a:t>The traffic line recovers in every case. The leads line is the one we are accountable for, and it moves faster because the first fixes land on the pages that convert.</a:t>
+              <a:t>Ramp is a volume publisher. Volume is the one game we cannot win on this budget, so we do not enter it.</a:t>
             </a:r>
             <a:endParaRPr lang="en-US" sz="1300" dirty="0"/>
           </a:p>
@@ -7705,7 +8288,7 @@
                 <a:ea typeface="Arial" pitchFamily="34" charset="-122"/>
                 <a:cs typeface="Arial" pitchFamily="34" charset="-120"/>
               </a:rPr>
-              <a:t>THE FIRST 90 DAYS</a:t>
+              <a:t>WHAT TO EXPECT</a:t>
             </a:r>
             <a:endParaRPr lang="en-US" sz="1100" dirty="0"/>
           </a:p>
@@ -7744,7 +8327,7 @@
                 <a:ea typeface="Arial" pitchFamily="34" charset="-122"/>
                 <a:cs typeface="Arial" pitchFamily="34" charset="-120"/>
               </a:rPr>
-              <a:t>You will see the first signals within 90 days, and we have agreed in advance what we do if they do not move.</a:t>
+              <a:t>By month 12: leads roughly double in the base case, and traffic lands between about 100K and 135K. 140K sits above our stretch case.</a:t>
             </a:r>
             <a:endParaRPr lang="en-US" sz="2600" dirty="0"/>
           </a:p>
@@ -7842,9 +8425,435 @@
           </a:p>
         </p:txBody>
       </p:sp>
+      <p:sp>
+        <p:nvSpPr>
+          <p:cNvPr id="7" name="Text 5"/>
+          <p:cNvSpPr/>
+          <p:nvPr/>
+        </p:nvSpPr>
+        <p:spPr>
+          <a:xfrm>
+            <a:off x="2743200" y="6355080"/>
+            <a:ext cx="8138160" cy="365760"/>
+          </a:xfrm>
+          <a:prstGeom prst="rect">
+            <a:avLst/>
+          </a:prstGeom>
+          <a:noFill/>
+          <a:ln/>
+        </p:spPr>
+        <p:txBody>
+          <a:bodyPr wrap="square" lIns="0" tIns="0" rIns="0" bIns="0" rtlCol="0" anchor="ctr"/>
+          <a:lstStyle/>
+          <a:p>
+            <a:pPr algn="r" indent="0" marL="0">
+              <a:buNone/>
+            </a:pPr>
+            <a:r>
+              <a:rPr lang="en-US" sz="850" dirty="0">
+                <a:solidFill>
+                  <a:srgbClr val="929194"/>
+                </a:solidFill>
+                <a:latin typeface="Arial" pitchFamily="34" charset="0"/>
+                <a:ea typeface="Arial" pitchFamily="34" charset="-122"/>
+                <a:cs typeface="Arial" pitchFamily="34" charset="-120"/>
+              </a:rPr>
+              <a:t>Three scenarios, not a forecast. The base case assumes the top-page sample's mix holds for the whole site; week-one Search Console data replaces that assumption.</a:t>
+            </a:r>
+            <a:endParaRPr lang="en-US" sz="850" dirty="0"/>
+          </a:p>
+        </p:txBody>
+      </p:sp>
       <p:graphicFrame>
         <p:nvGraphicFramePr>
-          <p:cNvPr id="14" name="Table 0"/>
+          <p:cNvPr id="8" name="Chart 0" descr=""/>
+          <p:cNvGraphicFramePr/>
+          <p:nvPr/>
+        </p:nvGraphicFramePr>
+        <p:xfrm>
+          <a:off x="548640" y="1828800"/>
+          <a:ext cx="5486400" cy="3200400"/>
+        </p:xfrm>
+        <a:graphic xmlns:a="http://schemas.openxmlformats.org/drawingml/2006/main">
+          <a:graphicData uri="http://schemas.openxmlformats.org/drawingml/2006/chart">
+            <c:chart xmlns:c="http://schemas.openxmlformats.org/drawingml/2006/chart" r:id="rId1"/>
+          </a:graphicData>
+        </a:graphic>
+      </p:graphicFrame>
+      <p:graphicFrame>
+        <p:nvGraphicFramePr>
+          <p:cNvPr id="9" name="Chart 1" descr=""/>
+          <p:cNvGraphicFramePr/>
+          <p:nvPr/>
+        </p:nvGraphicFramePr>
+        <p:xfrm>
+          <a:off x="6217920" y="1828800"/>
+          <a:ext cx="5394960" cy="3200400"/>
+        </p:xfrm>
+        <a:graphic xmlns:a="http://schemas.openxmlformats.org/drawingml/2006/main">
+          <a:graphicData uri="http://schemas.openxmlformats.org/drawingml/2006/chart">
+            <c:chart xmlns:c="http://schemas.openxmlformats.org/drawingml/2006/chart" r:id="rId2"/>
+          </a:graphicData>
+        </a:graphic>
+      </p:graphicFrame>
+      <p:sp>
+        <p:nvSpPr>
+          <p:cNvPr id="10" name="Text 6"/>
+          <p:cNvSpPr/>
+          <p:nvPr/>
+        </p:nvSpPr>
+        <p:spPr>
+          <a:xfrm>
+            <a:off x="548640" y="5074920"/>
+            <a:ext cx="11064240" cy="548640"/>
+          </a:xfrm>
+          <a:prstGeom prst="rect">
+            <a:avLst/>
+          </a:prstGeom>
+          <a:noFill/>
+          <a:ln/>
+        </p:spPr>
+        <p:txBody>
+          <a:bodyPr wrap="square" lIns="0" tIns="0" rIns="0" bIns="0" rtlCol="0" anchor="t"/>
+          <a:lstStyle/>
+          <a:p>
+            <a:pPr indent="0" marL="0">
+              <a:buNone/>
+            </a:pPr>
+            <a:r>
+              <a:rPr lang="en-US" sz="1100" dirty="0">
+                <a:solidFill>
+                  <a:srgbClr val="6C757D"/>
+                </a:solidFill>
+                <a:latin typeface="Arial" pitchFamily="34" charset="0"/>
+                <a:ea typeface="Arial" pitchFamily="34" charset="-122"/>
+                <a:cs typeface="Arial" pitchFamily="34" charset="-120"/>
+              </a:rPr>
+              <a:t>Month 12, base case: about 117,000 visits and 2.2x leads. Low: 101,000 and 1.5x. Stretch: 136,000 and 3x. Why even the stretch case stays under 140K: your biggest searches now have an AI answer on top, and the two expired pages were queries that government sites now own. Growth beyond the base case comes from new comparison pages and templates, not from the old pages returning to their old numbers.</a:t>
+            </a:r>
+            <a:endParaRPr lang="en-US" sz="1100" dirty="0"/>
+          </a:p>
+        </p:txBody>
+      </p:sp>
+      <p:sp>
+        <p:nvSpPr>
+          <p:cNvPr id="11" name="Shape 7"/>
+          <p:cNvSpPr/>
+          <p:nvPr/>
+        </p:nvSpPr>
+        <p:spPr>
+          <a:xfrm>
+            <a:off x="548640" y="5715000"/>
+            <a:ext cx="11064240" cy="502920"/>
+          </a:xfrm>
+          <a:prstGeom prst="rect">
+            <a:avLst/>
+          </a:prstGeom>
+          <a:solidFill>
+            <a:srgbClr val="E9EFF4"/>
+          </a:solidFill>
+          <a:ln w="12700">
+            <a:solidFill>
+              <a:srgbClr val="E9EFF4"/>
+            </a:solidFill>
+            <a:prstDash val="solid"/>
+          </a:ln>
+        </p:spPr>
+      </p:sp>
+      <p:sp>
+        <p:nvSpPr>
+          <p:cNvPr id="12" name="Shape 8"/>
+          <p:cNvSpPr/>
+          <p:nvPr/>
+        </p:nvSpPr>
+        <p:spPr>
+          <a:xfrm>
+            <a:off x="548640" y="5715000"/>
+            <a:ext cx="82296" cy="502920"/>
+          </a:xfrm>
+          <a:prstGeom prst="rect">
+            <a:avLst/>
+          </a:prstGeom>
+          <a:solidFill>
+            <a:srgbClr val="F27038"/>
+          </a:solidFill>
+          <a:ln w="12700">
+            <a:solidFill>
+              <a:srgbClr val="F27038"/>
+            </a:solidFill>
+            <a:prstDash val="solid"/>
+          </a:ln>
+        </p:spPr>
+      </p:sp>
+      <p:sp>
+        <p:nvSpPr>
+          <p:cNvPr id="13" name="Text 9"/>
+          <p:cNvSpPr/>
+          <p:nvPr/>
+        </p:nvSpPr>
+        <p:spPr>
+          <a:xfrm>
+            <a:off x="777240" y="5715000"/>
+            <a:ext cx="10698480" cy="502920"/>
+          </a:xfrm>
+          <a:prstGeom prst="rect">
+            <a:avLst/>
+          </a:prstGeom>
+          <a:noFill/>
+          <a:ln/>
+        </p:spPr>
+        <p:txBody>
+          <a:bodyPr wrap="square" lIns="0" tIns="0" rIns="0" bIns="0" rtlCol="0" anchor="ctr"/>
+          <a:lstStyle/>
+          <a:p>
+            <a:pPr indent="0" marL="0">
+              <a:buNone/>
+            </a:pPr>
+            <a:r>
+              <a:rPr lang="en-US" sz="1300" dirty="0">
+                <a:solidFill>
+                  <a:srgbClr val="2C2F33"/>
+                </a:solidFill>
+                <a:latin typeface="Arial" pitchFamily="34" charset="0"/>
+                <a:ea typeface="Arial" pitchFamily="34" charset="-122"/>
+                <a:cs typeface="Arial" pitchFamily="34" charset="-120"/>
+              </a:rPr>
+              <a:t>The traffic line recovers in every case. The leads line is the one we are accountable for, and it moves faster because the first fixes land on the pages that convert.</a:t>
+            </a:r>
+            <a:endParaRPr lang="en-US" sz="1300" dirty="0"/>
+          </a:p>
+        </p:txBody>
+      </p:sp>
+    </p:spTree>
+  </p:cSld>
+  <p:clrMapOvr>
+    <a:masterClrMapping/>
+  </p:clrMapOvr>
+</p:sld>
+</file>
+
+<file path=ppt/slides/slide14.xml><?xml version="1.0" encoding="utf-8"?>
+<p:sld xmlns:a="http://schemas.openxmlformats.org/drawingml/2006/main" xmlns:r="http://schemas.openxmlformats.org/officeDocument/2006/relationships" xmlns:p="http://schemas.openxmlformats.org/presentationml/2006/main">
+  <p:cSld name="Slide 14">
+    <p:bg>
+      <p:bgPr>
+        <a:solidFill>
+          <a:srgbClr val="FFFFFF"/>
+        </a:solidFill>
+      </p:bgPr>
+    </p:bg>
+    <p:spTree>
+      <p:nvGrpSpPr>
+        <p:cNvPr id="1" name=""/>
+        <p:cNvGrpSpPr/>
+        <p:nvPr/>
+      </p:nvGrpSpPr>
+      <p:grpSpPr>
+        <a:xfrm>
+          <a:off x="0" y="0"/>
+          <a:ext cx="0" cy="0"/>
+          <a:chOff x="0" y="0"/>
+          <a:chExt cx="0" cy="0"/>
+        </a:xfrm>
+      </p:grpSpPr>
+      <p:sp>
+        <p:nvSpPr>
+          <p:cNvPr id="2" name="Shape 0"/>
+          <p:cNvSpPr/>
+          <p:nvPr/>
+        </p:nvSpPr>
+        <p:spPr>
+          <a:xfrm>
+            <a:off x="0" y="0"/>
+            <a:ext cx="164592" cy="6858000"/>
+          </a:xfrm>
+          <a:prstGeom prst="rect">
+            <a:avLst/>
+          </a:prstGeom>
+          <a:solidFill>
+            <a:srgbClr val="F27038"/>
+          </a:solidFill>
+          <a:ln w="12700">
+            <a:solidFill>
+              <a:srgbClr val="F27038"/>
+            </a:solidFill>
+            <a:prstDash val="solid"/>
+          </a:ln>
+        </p:spPr>
+      </p:sp>
+      <p:sp>
+        <p:nvSpPr>
+          <p:cNvPr id="3" name="Text 1"/>
+          <p:cNvSpPr/>
+          <p:nvPr/>
+        </p:nvSpPr>
+        <p:spPr>
+          <a:xfrm>
+            <a:off x="548640" y="347472"/>
+            <a:ext cx="7315200" cy="274320"/>
+          </a:xfrm>
+          <a:prstGeom prst="rect">
+            <a:avLst/>
+          </a:prstGeom>
+          <a:noFill/>
+          <a:ln/>
+        </p:spPr>
+        <p:txBody>
+          <a:bodyPr wrap="square" lIns="0" tIns="0" rIns="0" bIns="0" rtlCol="0" anchor="ctr"/>
+          <a:lstStyle/>
+          <a:p>
+            <a:pPr indent="0" marL="0">
+              <a:buNone/>
+            </a:pPr>
+            <a:r>
+              <a:rPr lang="en-US" sz="1100" b="1" spc="200" kern="0" dirty="0">
+                <a:solidFill>
+                  <a:srgbClr val="F27038"/>
+                </a:solidFill>
+                <a:latin typeface="Arial" pitchFamily="34" charset="0"/>
+                <a:ea typeface="Arial" pitchFamily="34" charset="-122"/>
+                <a:cs typeface="Arial" pitchFamily="34" charset="-120"/>
+              </a:rPr>
+              <a:t>THE FIRST 90 DAYS</a:t>
+            </a:r>
+            <a:endParaRPr lang="en-US" sz="1100" dirty="0"/>
+          </a:p>
+        </p:txBody>
+      </p:sp>
+      <p:sp>
+        <p:nvSpPr>
+          <p:cNvPr id="4" name="Text 2"/>
+          <p:cNvSpPr/>
+          <p:nvPr/>
+        </p:nvSpPr>
+        <p:spPr>
+          <a:xfrm>
+            <a:off x="548640" y="640080"/>
+            <a:ext cx="11064240" cy="1005840"/>
+          </a:xfrm>
+          <a:prstGeom prst="rect">
+            <a:avLst/>
+          </a:prstGeom>
+          <a:noFill/>
+          <a:ln/>
+        </p:spPr>
+        <p:txBody>
+          <a:bodyPr wrap="square" lIns="0" tIns="0" rIns="0" bIns="0" rtlCol="0" anchor="t"/>
+          <a:lstStyle/>
+          <a:p>
+            <a:pPr indent="0" marL="0">
+              <a:buNone/>
+            </a:pPr>
+            <a:r>
+              <a:rPr lang="en-US" sz="2600" b="1" dirty="0">
+                <a:solidFill>
+                  <a:srgbClr val="2F343A"/>
+                </a:solidFill>
+                <a:latin typeface="Arial" pitchFamily="34" charset="0"/>
+                <a:ea typeface="Arial" pitchFamily="34" charset="-122"/>
+                <a:cs typeface="Arial" pitchFamily="34" charset="-120"/>
+              </a:rPr>
+              <a:t>You will see the first signals within 90 days, and we have agreed in advance what we do if they do not move.</a:t>
+            </a:r>
+            <a:endParaRPr lang="en-US" sz="2600" dirty="0"/>
+          </a:p>
+        </p:txBody>
+      </p:sp>
+      <p:sp>
+        <p:nvSpPr>
+          <p:cNvPr id="5" name="Text 3"/>
+          <p:cNvSpPr/>
+          <p:nvPr/>
+        </p:nvSpPr>
+        <p:spPr>
+          <a:xfrm>
+            <a:off x="548640" y="6355080"/>
+            <a:ext cx="2011680" cy="365760"/>
+          </a:xfrm>
+          <a:prstGeom prst="rect">
+            <a:avLst/>
+          </a:prstGeom>
+          <a:noFill/>
+          <a:ln/>
+        </p:spPr>
+        <p:txBody>
+          <a:bodyPr wrap="square" lIns="0" tIns="0" rIns="0" bIns="0" rtlCol="0" anchor="ctr"/>
+          <a:lstStyle/>
+          <a:p>
+            <a:pPr indent="0" marL="0">
+              <a:buNone/>
+            </a:pPr>
+            <a:r>
+              <a:rPr lang="en-US" sz="1100" b="1" dirty="0">
+                <a:solidFill>
+                  <a:srgbClr val="2F343A"/>
+                </a:solidFill>
+                <a:latin typeface="Arial" pitchFamily="34" charset="0"/>
+                <a:ea typeface="Arial" pitchFamily="34" charset="-122"/>
+                <a:cs typeface="Arial" pitchFamily="34" charset="-120"/>
+              </a:rPr>
+              <a:t>Single</a:t>
+            </a:r>
+            <a:pPr indent="0" marL="0">
+              <a:buNone/>
+            </a:pPr>
+            <a:r>
+              <a:rPr lang="en-US" sz="1100" b="1" dirty="0">
+                <a:solidFill>
+                  <a:srgbClr val="F27038"/>
+                </a:solidFill>
+                <a:latin typeface="Arial" pitchFamily="34" charset="0"/>
+                <a:ea typeface="Arial" pitchFamily="34" charset="-122"/>
+                <a:cs typeface="Arial" pitchFamily="34" charset="-120"/>
+              </a:rPr>
+              <a:t>Grain</a:t>
+            </a:r>
+            <a:endParaRPr lang="en-US" sz="1100" dirty="0"/>
+          </a:p>
+        </p:txBody>
+      </p:sp>
+      <p:sp>
+        <p:nvSpPr>
+          <p:cNvPr id="6" name="Text 4"/>
+          <p:cNvSpPr/>
+          <p:nvPr/>
+        </p:nvSpPr>
+        <p:spPr>
+          <a:xfrm>
+            <a:off x="11094415" y="6355080"/>
+            <a:ext cx="548640" cy="365760"/>
+          </a:xfrm>
+          <a:prstGeom prst="rect">
+            <a:avLst/>
+          </a:prstGeom>
+          <a:noFill/>
+          <a:ln/>
+        </p:spPr>
+        <p:txBody>
+          <a:bodyPr wrap="square" lIns="0" tIns="0" rIns="0" bIns="0" rtlCol="0" anchor="ctr"/>
+          <a:lstStyle/>
+          <a:p>
+            <a:pPr algn="r" indent="0" marL="0">
+              <a:buNone/>
+            </a:pPr>
+            <a:r>
+              <a:rPr lang="en-US" sz="1000" dirty="0">
+                <a:solidFill>
+                  <a:srgbClr val="929194"/>
+                </a:solidFill>
+                <a:latin typeface="Arial" pitchFamily="34" charset="0"/>
+                <a:ea typeface="Arial" pitchFamily="34" charset="-122"/>
+                <a:cs typeface="Arial" pitchFamily="34" charset="-120"/>
+              </a:rPr>
+              <a:t>14</a:t>
+            </a:r>
+            <a:endParaRPr lang="en-US" sz="1000" dirty="0"/>
+          </a:p>
+        </p:txBody>
+      </p:sp>
+      <p:graphicFrame>
+        <p:nvGraphicFramePr>
+          <p:cNvPr id="15" name="Table 0"/>
           <p:cNvGraphicFramePr>
             <a:graphicFrameLocks noGrp="1"/>
           </p:cNvGraphicFramePr>
@@ -9206,9 +10215,9 @@
 </p:sld>
 </file>
 
-<file path=ppt/slides/slide14.xml><?xml version="1.0" encoding="utf-8"?>
+<file path=ppt/slides/slide15.xml><?xml version="1.0" encoding="utf-8"?>
 <p:sld xmlns:a="http://schemas.openxmlformats.org/drawingml/2006/main" xmlns:r="http://schemas.openxmlformats.org/officeDocument/2006/relationships" xmlns:p="http://schemas.openxmlformats.org/presentationml/2006/main">
-  <p:cSld name="Slide 14">
+  <p:cSld name="Slide 15">
     <p:bg>
       <p:bgPr>
         <a:solidFill>
@@ -9419,7 +10428,7 @@
                 <a:ea typeface="Arial" pitchFamily="34" charset="-122"/>
                 <a:cs typeface="Arial" pitchFamily="34" charset="-120"/>
               </a:rPr>
-              <a:t>14</a:t>
+              <a:t>15</a:t>
             </a:r>
             <a:endParaRPr lang="en-US" sz="1000" dirty="0"/>
           </a:p>
@@ -9976,9 +10985,9 @@
 </p:sld>
 </file>
 
-<file path=ppt/slides/slide15.xml><?xml version="1.0" encoding="utf-8"?>
+<file path=ppt/slides/slide16.xml><?xml version="1.0" encoding="utf-8"?>
 <p:sld xmlns:a="http://schemas.openxmlformats.org/drawingml/2006/main" xmlns:r="http://schemas.openxmlformats.org/officeDocument/2006/relationships" xmlns:p="http://schemas.openxmlformats.org/presentationml/2006/main">
-  <p:cSld name="Slide 15">
+  <p:cSld name="Slide 16">
     <p:bg>
       <p:bgPr>
         <a:solidFill>

</xml_diff>